<commit_message>
Simulation results are now being reviewed. Experimenting with different tables and plots to determine best way to present the simulation results. Heatmap appears to be the best so far to conserve space. Updates to final reports results section have been made.
</commit_message>
<xml_diff>
--- a/Project4/Reports/Interim_presentation_slides_summers.pptx
+++ b/Project4/Reports/Interim_presentation_slides_summers.pptx
@@ -14,7 +14,7 @@
     <p:sldId id="259" r:id="rId5"/>
   </p:sldIdLst>
   <p:sldSz cx="12192000" cy="6858000"/>
-  <p:notesSz cx="12192000" cy="6858000"/>
+  <p:notesSz cx="6858000" cy="12192000"/>
   <p:embeddedFontLst>
     <p:embeddedFont>
       <p:font typeface="Cambria Math" panose="02040503050406030204" pitchFamily="18" charset="0"/>
@@ -25,7 +25,7 @@
       <p:regular r:id="rId8"/>
     </p:embeddedFont>
     <p:embeddedFont>
-      <p:font typeface="WPQCJM+FranklinGothic-Book" panose="02000500000000000000"/>
+      <p:font typeface="WPQCJM+FranklinGothic-Book" panose="02000500000000000000" pitchFamily="2" charset="0"/>
       <p:regular r:id="rId9"/>
     </p:embeddedFont>
   </p:embeddedFontLst>
@@ -178,7 +178,7 @@
         <p:spPr>
           <a:xfrm>
             <a:off x="0" y="0"/>
-            <a:ext cx="5283200" cy="344488"/>
+            <a:ext cx="2971800" cy="612423"/>
           </a:xfrm>
           <a:prstGeom prst="rect">
             <a:avLst/>
@@ -208,8 +208,8 @@
         </p:nvSpPr>
         <p:spPr>
           <a:xfrm>
-            <a:off x="6905625" y="0"/>
-            <a:ext cx="5283200" cy="344488"/>
+            <a:off x="3884414" y="0"/>
+            <a:ext cx="2971800" cy="612423"/>
           </a:xfrm>
           <a:prstGeom prst="rect">
             <a:avLst/>
@@ -225,7 +225,7 @@
           <a:p>
             <a:fld id="{5572088B-D286-3046-B6F7-B15DDA392F38}" type="datetimeFigureOut">
               <a:rPr lang="en-US" smtClean="0"/>
-              <a:t>5/1/26</a:t>
+              <a:t>5/4/26</a:t>
             </a:fld>
             <a:endParaRPr lang="en-US"/>
           </a:p>
@@ -243,8 +243,8 @@
         </p:nvSpPr>
         <p:spPr>
           <a:xfrm>
-            <a:off x="4038600" y="857250"/>
-            <a:ext cx="4114800" cy="2314575"/>
+            <a:off x="-228600" y="1524000"/>
+            <a:ext cx="7315200" cy="4114800"/>
           </a:xfrm>
           <a:prstGeom prst="rect">
             <a:avLst/>
@@ -276,8 +276,8 @@
         </p:nvSpPr>
         <p:spPr>
           <a:xfrm>
-            <a:off x="1219200" y="3300413"/>
-            <a:ext cx="9753600" cy="2700337"/>
+            <a:off x="685800" y="5867405"/>
+            <a:ext cx="5486400" cy="4800599"/>
           </a:xfrm>
           <a:prstGeom prst="rect">
             <a:avLst/>
@@ -335,8 +335,8 @@
         </p:nvSpPr>
         <p:spPr>
           <a:xfrm>
-            <a:off x="0" y="6513513"/>
-            <a:ext cx="5283200" cy="344487"/>
+            <a:off x="0" y="11579583"/>
+            <a:ext cx="2971800" cy="612421"/>
           </a:xfrm>
           <a:prstGeom prst="rect">
             <a:avLst/>
@@ -366,8 +366,8 @@
         </p:nvSpPr>
         <p:spPr>
           <a:xfrm>
-            <a:off x="6905625" y="6513513"/>
-            <a:ext cx="5283200" cy="344487"/>
+            <a:off x="3884414" y="11579583"/>
+            <a:ext cx="2971800" cy="612421"/>
           </a:xfrm>
           <a:prstGeom prst="rect">
             <a:avLst/>
@@ -635,82 +635,42 @@
           <a:lstStyle/>
           <a:p>
             <a:r>
-              <a:rPr lang="en-US" dirty="0"/>
-              <a:t>So, the main research question we’re trying to answer is how different variable selection methods perform in identifying true predictors and excluding irrelevant ones in linear regression models under varying sample sizes and correlations</a:t>
-            </a:r>
-          </a:p>
-          <a:p>
-            <a:endParaRPr lang="en-US" dirty="0"/>
-          </a:p>
-          <a:p>
-            <a:pPr marL="0" marR="0" lvl="0" indent="0" algn="l" defTabSz="914400" rtl="0" eaLnBrk="1" fontAlgn="auto" latinLnBrk="0" hangingPunct="1">
-              <a:lnSpc>
-                <a:spcPct val="100000"/>
-              </a:lnSpc>
-              <a:spcBef>
-                <a:spcPts val="0"/>
-              </a:spcBef>
-              <a:spcAft>
-                <a:spcPts val="0"/>
-              </a:spcAft>
-              <a:buClrTx/>
-              <a:buSzTx/>
-              <a:buFontTx/>
-              <a:buNone/>
-              <a:tabLst/>
-              <a:defRPr/>
-            </a:pPr>
-            <a:r>
-              <a:rPr lang="en-US" dirty="0"/>
-              <a:t>The main goals are to compare selection accuracy, evaluate estimation performance, and assess Type I and Type II error.</a:t>
-            </a:r>
-          </a:p>
-          <a:p>
-            <a:endParaRPr lang="en-US" dirty="0"/>
-          </a:p>
-          <a:p>
-            <a:r>
-              <a:rPr lang="en-US" dirty="0"/>
-              <a:t>To study this, we will simulate data under a linear regression model using the hdrm package </a:t>
-            </a:r>
-          </a:p>
-          <a:p>
-            <a:endParaRPr lang="en-US" dirty="0"/>
-          </a:p>
-          <a:p>
-            <a:r>
-              <a:rPr lang="en-US" dirty="0"/>
-              <a:t>In each of the simulated datasets, we include 20 continuous predictors, but only 5 of them are truly associated with the outcome with non-zero effects, while the remaining 15 are null variables with effects set to zero.</a:t>
-            </a:r>
-          </a:p>
-          <a:p>
-            <a:endParaRPr lang="en-US" dirty="0"/>
-          </a:p>
-          <a:p>
-            <a:r>
-              <a:rPr lang="en-US" dirty="0"/>
-              <a:t>We then vary two key parameters of the data-generating process. First, we vary the sample size, using 250 and 500 observations.</a:t>
-            </a:r>
-          </a:p>
-          <a:p>
-            <a:endParaRPr lang="en-US" dirty="0"/>
-          </a:p>
-          <a:p>
-            <a:r>
-              <a:rPr lang="en-US" dirty="0"/>
-              <a:t>Second, we vary the level of correlation among predictors using an exchangeable structure, with correlation values of 0, 0.35, and 0.7.</a:t>
-            </a:r>
-          </a:p>
-          <a:p>
-            <a:endParaRPr lang="en-US" dirty="0"/>
-          </a:p>
-          <a:p>
-            <a:r>
-              <a:rPr lang="en-US" dirty="0"/>
-              <a:t>This gives us six scenarios, which will allow us to evaluate how each of these method performs under different conditions.</a:t>
-            </a:r>
-          </a:p>
-          <a:p>
+              <a:rPr lang="en-US" sz="1200" b="0" i="0" u="none" strike="noStrike" kern="1200" dirty="0">
+                <a:solidFill>
+                  <a:schemeClr val="tx1"/>
+                </a:solidFill>
+                <a:effectLst/>
+                <a:latin typeface="+mn-lt"/>
+                <a:ea typeface="+mn-ea"/>
+                <a:cs typeface="+mn-cs"/>
+              </a:rPr>
+              <a:t>The main research question guiding this project is: how do different variable selection methods perform in identifying true predictors and excluding irrelevant ones under varying sample sizes and correlations</a:t>
+            </a:r>
+          </a:p>
+          <a:p>
+            <a:endParaRPr lang="en-US" sz="1200" b="0" i="0" u="none" strike="noStrike" kern="1200" dirty="0">
+              <a:solidFill>
+                <a:schemeClr val="tx1"/>
+              </a:solidFill>
+              <a:effectLst/>
+              <a:latin typeface="+mn-lt"/>
+              <a:ea typeface="+mn-ea"/>
+              <a:cs typeface="+mn-cs"/>
+            </a:endParaRPr>
+          </a:p>
+          <a:p>
+            <a:r>
+              <a:rPr lang="en-US" sz="1200" b="0" i="0" u="none" strike="noStrike" kern="1200" dirty="0">
+                <a:solidFill>
+                  <a:schemeClr val="tx1"/>
+                </a:solidFill>
+                <a:effectLst/>
+                <a:latin typeface="+mn-lt"/>
+                <a:ea typeface="+mn-ea"/>
+                <a:cs typeface="+mn-cs"/>
+              </a:rPr>
+              <a:t>To address this, we have three aims: comparing variable selection accuracy across methods, evaluating coefficient estimation performance, and assessing Type I and Type II error rates</a:t>
+            </a:r>
             <a:endParaRPr lang="en-US" dirty="0"/>
           </a:p>
         </p:txBody>
@@ -803,8 +763,147 @@
           <a:lstStyle/>
           <a:p>
             <a:r>
+              <a:rPr lang="en-US" sz="1200" kern="1200" dirty="0">
+                <a:solidFill>
+                  <a:schemeClr val="tx1"/>
+                </a:solidFill>
+                <a:effectLst/>
+                <a:latin typeface="+mn-lt"/>
+                <a:ea typeface="+mn-ea"/>
+                <a:cs typeface="+mn-cs"/>
+              </a:rPr>
+              <a:t>Starting with sim design, we will simulate data under a linear regression model using the ‘hdrm’ package </a:t>
+            </a:r>
+          </a:p>
+          <a:p>
+            <a:endParaRPr lang="en-US" sz="1200" kern="1200" dirty="0">
+              <a:solidFill>
+                <a:schemeClr val="tx1"/>
+              </a:solidFill>
+              <a:effectLst/>
+              <a:latin typeface="+mn-lt"/>
+              <a:ea typeface="+mn-ea"/>
+              <a:cs typeface="+mn-cs"/>
+            </a:endParaRPr>
+          </a:p>
+          <a:p>
+            <a:r>
+              <a:rPr lang="en-US" sz="1200" kern="1200" dirty="0">
+                <a:solidFill>
+                  <a:schemeClr val="tx1"/>
+                </a:solidFill>
+                <a:effectLst/>
+                <a:latin typeface="+mn-lt"/>
+                <a:ea typeface="+mn-ea"/>
+                <a:cs typeface="+mn-cs"/>
+              </a:rPr>
+              <a:t>Each simulated dataset will include 20 continuous predictors, but only 5 of them are truly associated with the outcome, while the remaining 15 are null.</a:t>
+            </a:r>
+          </a:p>
+          <a:p>
+            <a:endParaRPr lang="en-US" sz="1200" kern="1200" dirty="0">
+              <a:solidFill>
+                <a:schemeClr val="tx1"/>
+              </a:solidFill>
+              <a:effectLst/>
+              <a:latin typeface="+mn-lt"/>
+              <a:ea typeface="+mn-ea"/>
+              <a:cs typeface="+mn-cs"/>
+            </a:endParaRPr>
+          </a:p>
+          <a:p>
+            <a:r>
+              <a:rPr lang="en-US" sz="1200" kern="1200" dirty="0">
+                <a:solidFill>
+                  <a:schemeClr val="tx1"/>
+                </a:solidFill>
+                <a:effectLst/>
+                <a:latin typeface="+mn-lt"/>
+                <a:ea typeface="+mn-ea"/>
+                <a:cs typeface="+mn-cs"/>
+              </a:rPr>
+              <a:t>We then vary two parameters of this data-generating process. </a:t>
+            </a:r>
+          </a:p>
+          <a:p>
+            <a:endParaRPr lang="en-US" sz="1200" kern="1200" dirty="0">
+              <a:solidFill>
+                <a:schemeClr val="tx1"/>
+              </a:solidFill>
+              <a:effectLst/>
+              <a:latin typeface="+mn-lt"/>
+              <a:ea typeface="+mn-ea"/>
+              <a:cs typeface="+mn-cs"/>
+            </a:endParaRPr>
+          </a:p>
+          <a:p>
+            <a:r>
+              <a:rPr lang="en-US" sz="1200" kern="1200" dirty="0">
+                <a:solidFill>
+                  <a:schemeClr val="tx1"/>
+                </a:solidFill>
+                <a:effectLst/>
+                <a:latin typeface="+mn-lt"/>
+                <a:ea typeface="+mn-ea"/>
+                <a:cs typeface="+mn-cs"/>
+              </a:rPr>
+              <a:t>The sample size, using 250 and 500 observations and correlation among the predictors using an exchangeable structure with values 0, 0.35, and 0.7.</a:t>
+            </a:r>
+          </a:p>
+          <a:p>
+            <a:r>
+              <a:rPr lang="en-US" sz="1200" kern="1200" dirty="0">
+                <a:solidFill>
+                  <a:schemeClr val="tx1"/>
+                </a:solidFill>
+                <a:effectLst/>
+                <a:latin typeface="+mn-lt"/>
+                <a:ea typeface="+mn-ea"/>
+                <a:cs typeface="+mn-cs"/>
+              </a:rPr>
+              <a:t>Which will give us six scenarios to evaluate .</a:t>
+            </a:r>
+          </a:p>
+          <a:p>
+            <a:endParaRPr lang="en-US" sz="1200" b="0" i="0" u="none" strike="noStrike" kern="1200" dirty="0">
+              <a:solidFill>
+                <a:schemeClr val="tx1"/>
+              </a:solidFill>
+              <a:effectLst/>
+              <a:latin typeface="+mn-lt"/>
+              <a:ea typeface="+mn-ea"/>
+              <a:cs typeface="+mn-cs"/>
+            </a:endParaRPr>
+          </a:p>
+          <a:p>
+            <a:r>
+              <a:rPr lang="en-US" sz="1200" b="0" i="0" u="none" strike="noStrike" kern="1200" dirty="0">
+                <a:solidFill>
+                  <a:schemeClr val="tx1"/>
+                </a:solidFill>
+                <a:effectLst/>
+                <a:latin typeface="+mn-lt"/>
+                <a:ea typeface="+mn-ea"/>
+                <a:cs typeface="+mn-cs"/>
+              </a:rPr>
+              <a:t>Across these six scenarios we will be comparing seven selection methods </a:t>
+            </a:r>
+          </a:p>
+          <a:p>
+            <a:endParaRPr lang="en-US" sz="1200" b="0" i="0" u="none" strike="noStrike" kern="1200" dirty="0">
+              <a:solidFill>
+                <a:schemeClr val="tx1"/>
+              </a:solidFill>
+              <a:effectLst/>
+              <a:latin typeface="+mn-lt"/>
+              <a:ea typeface="+mn-ea"/>
+              <a:cs typeface="+mn-cs"/>
+            </a:endParaRPr>
+          </a:p>
+          <a:p>
+            <a:r>
               <a:rPr lang="en-US" dirty="0"/>
-              <a:t>On to the selection methods,</a:t>
+              <a:t>The first group consists of backward selection approaches, which iteratively remove predictors based on different criteria: in our case, variables are removed if their p-value exceeds 0.157, or if removing them improves model fit according to AIC or BIC</a:t>
             </a:r>
           </a:p>
           <a:p>
@@ -813,81 +912,118 @@
           <a:p>
             <a:r>
               <a:rPr lang="en-US" dirty="0"/>
-              <a:t>For each simulated dataset, we begin by fitting the linear regression model with all 20 predictors.</a:t>
-            </a:r>
-          </a:p>
-          <a:p>
-            <a:endParaRPr lang="en-US" dirty="0"/>
-          </a:p>
-          <a:p>
+              <a:t>The second group consists of penalized regression methods, including LASSO, which applies a penalty that can shrink coefficients to zero, and elastic net, that uses a combination of penalties is said to perform better when predictors are highly correlated.</a:t>
+            </a:r>
+          </a:p>
+          <a:p>
+            <a:endParaRPr lang="en-US" sz="1200" kern="1200" dirty="0">
+              <a:solidFill>
+                <a:schemeClr val="tx1"/>
+              </a:solidFill>
+              <a:effectLst/>
+              <a:latin typeface="+mn-lt"/>
+              <a:ea typeface="+mn-ea"/>
+              <a:cs typeface="+mn-cs"/>
+            </a:endParaRPr>
+          </a:p>
+          <a:p>
+            <a:pPr marL="0" marR="0" lvl="0" indent="0" algn="l" defTabSz="914400" rtl="0" eaLnBrk="1" fontAlgn="auto" latinLnBrk="0" hangingPunct="1">
+              <a:lnSpc>
+                <a:spcPct val="100000"/>
+              </a:lnSpc>
+              <a:spcBef>
+                <a:spcPts val="0"/>
+              </a:spcBef>
+              <a:spcAft>
+                <a:spcPts val="0"/>
+              </a:spcAft>
+              <a:buClrTx/>
+              <a:buSzTx/>
+              <a:buFontTx/>
+              <a:buNone/>
+              <a:tabLst/>
+              <a:defRPr/>
+            </a:pPr>
+            <a:r>
+              <a:rPr lang="en-US" sz="1200" kern="1200" dirty="0">
+                <a:solidFill>
+                  <a:schemeClr val="tx1"/>
+                </a:solidFill>
+                <a:effectLst/>
+                <a:latin typeface="+mn-lt"/>
+                <a:ea typeface="+mn-ea"/>
+                <a:cs typeface="+mn-cs"/>
+              </a:rPr>
+              <a:t>For both, the tuning parameter lambda will be selected by 10-fold cross-validation, and two lambdas will be investigated, one that minimizes CV prediction error and a more conservative choice within 1 SE of that minimum.</a:t>
+            </a:r>
+          </a:p>
+          <a:p>
+            <a:endParaRPr lang="en-US" sz="1200" kern="1200" dirty="0">
+              <a:solidFill>
+                <a:schemeClr val="tx1"/>
+              </a:solidFill>
+              <a:effectLst/>
+              <a:latin typeface="+mn-lt"/>
+              <a:ea typeface="+mn-ea"/>
+              <a:cs typeface="+mn-cs"/>
+            </a:endParaRPr>
+          </a:p>
+          <a:p>
+            <a:pPr marL="0" marR="0" lvl="0" indent="0" algn="l" defTabSz="914400" rtl="0" eaLnBrk="1" fontAlgn="auto" latinLnBrk="0" hangingPunct="1">
+              <a:lnSpc>
+                <a:spcPct val="100000"/>
+              </a:lnSpc>
+              <a:spcBef>
+                <a:spcPts val="0"/>
+              </a:spcBef>
+              <a:spcAft>
+                <a:spcPts val="0"/>
+              </a:spcAft>
+              <a:buClrTx/>
+              <a:buSzTx/>
+              <a:buFontTx/>
+              <a:buNone/>
+              <a:tabLst/>
+              <a:defRPr/>
+            </a:pPr>
+            <a:r>
+              <a:rPr lang="el-GR" b="1" dirty="0"/>
+              <a:t>λ_</a:t>
+            </a:r>
+            <a:r>
+              <a:rPr lang="en-US" b="1" dirty="0"/>
+              <a:t>min</a:t>
+            </a:r>
             <a:r>
               <a:rPr lang="en-US" dirty="0"/>
-              <a:t>We will then apply two types of selection methods.</a:t>
+              <a:t> → higher FP, lower FN (misses)</a:t>
             </a:r>
             <a:br>
               <a:rPr lang="en-US" dirty="0"/>
             </a:br>
-            <a:endParaRPr lang="en-US" dirty="0"/>
-          </a:p>
-          <a:p>
+            <a:r>
+              <a:rPr lang="el-GR" b="1" dirty="0"/>
+              <a:t>λ_1</a:t>
+            </a:r>
+            <a:r>
+              <a:rPr lang="en-US" b="1" dirty="0"/>
+              <a:t>se</a:t>
+            </a:r>
             <a:r>
               <a:rPr lang="en-US" dirty="0"/>
-              <a:t>The first method is backward selection with three criteria. These include p-value–based selection using a threshold of 0.15, as well as AIC and BIC, </a:t>
-            </a:r>
-          </a:p>
-          <a:p>
-            <a:r>
-              <a:rPr lang="en-US" dirty="0"/>
-              <a:t>Where BIC typically favors simpler models due to its stronger penalty.</a:t>
-            </a:r>
-            <a:br>
-              <a:rPr lang="en-US" dirty="0"/>
-            </a:br>
-            <a:endParaRPr lang="en-US" dirty="0"/>
-          </a:p>
-          <a:p>
-            <a:r>
-              <a:rPr lang="en-US" dirty="0"/>
-              <a:t>The second method is penalized regression methods. These include LASSO, which can shrink coefficients exactly to zero and perform variable selection, </a:t>
-            </a:r>
-          </a:p>
-          <a:p>
-            <a:r>
-              <a:rPr lang="en-US" dirty="0"/>
-              <a:t>and elastic net, which combines L1 and L2 penalties and is particularly useful when predictors are correlated.</a:t>
-            </a:r>
-          </a:p>
-          <a:p>
-            <a:endParaRPr lang="en-US" dirty="0"/>
-          </a:p>
-          <a:p>
-            <a:r>
-              <a:rPr lang="en-US" dirty="0"/>
-              <a:t>For both LASSO and elastic net, the tuning parameter lambda will be selected by using 10-fold cross-validation, and consider two lambdas, one that minimizes CV prediction error and a more conservative choice within 1 SE of that minimum.</a:t>
-            </a:r>
-          </a:p>
-          <a:p>
-            <a:endParaRPr lang="en-US" dirty="0"/>
-          </a:p>
-          <a:p>
-            <a:r>
-              <a:rPr lang="el-GR" dirty="0"/>
-              <a:t>Λ</a:t>
-            </a:r>
-            <a:r>
-              <a:rPr lang="en-US" dirty="0"/>
-              <a:t>≈0=more complexity=higher variance-lower bias</a:t>
-            </a:r>
-          </a:p>
-          <a:p>
-            <a:r>
-              <a:rPr lang="el-GR" dirty="0"/>
-              <a:t>Λ</a:t>
-            </a:r>
-            <a:r>
-              <a:rPr lang="en-US" dirty="0"/>
-              <a:t>&gt;0=increases regularization, which reduces complexity=lower variance-higher bias</a:t>
-            </a:r>
+              <a:t> → lower FP, higher FN</a:t>
+            </a:r>
+          </a:p>
+          <a:p>
+            <a:endParaRPr lang="en-US" sz="1200" kern="1200" dirty="0">
+              <a:solidFill>
+                <a:schemeClr val="tx1"/>
+              </a:solidFill>
+              <a:effectLst/>
+              <a:latin typeface="+mn-lt"/>
+              <a:ea typeface="+mn-ea"/>
+              <a:cs typeface="+mn-cs"/>
+            </a:endParaRPr>
           </a:p>
           <a:p>
             <a:endParaRPr lang="en-US" dirty="0"/>
@@ -984,9 +1120,132 @@
           <a:bodyPr/>
           <a:lstStyle/>
           <a:p>
+            <a:pPr lvl="0"/>
+            <a:r>
+              <a:rPr lang="en-US" sz="1200" b="0" i="0" u="none" strike="noStrike" kern="1200" dirty="0">
+                <a:solidFill>
+                  <a:schemeClr val="tx1"/>
+                </a:solidFill>
+                <a:effectLst/>
+                <a:latin typeface="+mn-lt"/>
+                <a:ea typeface="+mn-ea"/>
+                <a:cs typeface="+mn-cs"/>
+              </a:rPr>
+              <a:t>For the simulation workflow, we will generate a dataset, fit the full model with all 20 predictors, and apply each selection method to obtain a final variable set. </a:t>
+            </a:r>
+          </a:p>
+          <a:p>
+            <a:pPr lvl="0"/>
+            <a:r>
+              <a:rPr lang="en-US" sz="1200" b="0" i="0" u="none" strike="noStrike" kern="1200" dirty="0">
+                <a:solidFill>
+                  <a:schemeClr val="tx1"/>
+                </a:solidFill>
+                <a:effectLst/>
+                <a:latin typeface="+mn-lt"/>
+                <a:ea typeface="+mn-ea"/>
+                <a:cs typeface="+mn-cs"/>
+              </a:rPr>
+              <a:t>We then refit the model using only the selected variables so we can compare </a:t>
+            </a:r>
+            <a:r>
+              <a:rPr lang="en-US" b="0" dirty="0"/>
+              <a:t>estimates to the true </a:t>
+            </a:r>
+            <a:r>
+              <a:rPr lang="el-GR" b="0" dirty="0"/>
+              <a:t>β </a:t>
+            </a:r>
+            <a:r>
+              <a:rPr lang="en-US" b="0" dirty="0"/>
+              <a:t>values</a:t>
+            </a:r>
+          </a:p>
+          <a:p>
+            <a:pPr lvl="0"/>
+            <a:endParaRPr lang="en-US" sz="1200" b="0" i="0" u="none" strike="noStrike" kern="1200" dirty="0">
+              <a:solidFill>
+                <a:schemeClr val="tx1"/>
+              </a:solidFill>
+              <a:effectLst/>
+              <a:latin typeface="+mn-lt"/>
+              <a:ea typeface="+mn-ea"/>
+              <a:cs typeface="+mn-cs"/>
+            </a:endParaRPr>
+          </a:p>
+          <a:p>
+            <a:pPr lvl="0"/>
+            <a:r>
+              <a:rPr lang="en-US" sz="1200" b="0" i="0" u="none" strike="noStrike" kern="1200" dirty="0">
+                <a:solidFill>
+                  <a:schemeClr val="tx1"/>
+                </a:solidFill>
+                <a:effectLst/>
+                <a:latin typeface="+mn-lt"/>
+                <a:ea typeface="+mn-ea"/>
+                <a:cs typeface="+mn-cs"/>
+              </a:rPr>
+              <a:t>This process repeats 10,000 times per scenario, and results will be summarized as averages across iterations.</a:t>
+            </a:r>
+          </a:p>
+          <a:p>
+            <a:pPr lvl="0"/>
+            <a:endParaRPr lang="en-US" sz="1200" b="0" i="0" u="none" strike="noStrike" kern="1200" dirty="0">
+              <a:solidFill>
+                <a:schemeClr val="tx1"/>
+              </a:solidFill>
+              <a:effectLst/>
+              <a:latin typeface="+mn-lt"/>
+              <a:ea typeface="+mn-ea"/>
+              <a:cs typeface="+mn-cs"/>
+            </a:endParaRPr>
+          </a:p>
+          <a:p>
+            <a:r>
+              <a:rPr lang="en-US" sz="1200" b="0" i="0" u="none" strike="noStrike" kern="1200" dirty="0">
+                <a:solidFill>
+                  <a:schemeClr val="tx1"/>
+                </a:solidFill>
+                <a:effectLst/>
+                <a:latin typeface="+mn-lt"/>
+                <a:ea typeface="+mn-ea"/>
+                <a:cs typeface="+mn-cs"/>
+              </a:rPr>
+              <a:t>Each Methods Performance will be assessed across two areas. </a:t>
+            </a:r>
             <a:r>
               <a:rPr lang="en-US" dirty="0"/>
-              <a:t>For each scenario, we start by generating a dataset based on the sample size and correlation level.</a:t>
+              <a:t>For variable selection, we evaluate how well each method identifies true predictors and avoids selecting null variables, using measures like sensitivity and false positive rate, along with mean model size as a measure of complexity</a:t>
+            </a:r>
+          </a:p>
+          <a:p>
+            <a:pPr lvl="0"/>
+            <a:endParaRPr lang="en-US" sz="1200" dirty="0">
+              <a:solidFill>
+                <a:schemeClr val="bg1"/>
+              </a:solidFill>
+            </a:endParaRPr>
+          </a:p>
+          <a:p>
+            <a:pPr lvl="0"/>
+            <a:r>
+              <a:rPr lang="en-US" sz="1200" dirty="0">
+                <a:solidFill>
+                  <a:schemeClr val="bg1"/>
+                </a:solidFill>
+              </a:rPr>
+              <a:t>For estimation, we evaluate bias, 95% CI coverage, and Type I and Type II error rates. - with the key detail</a:t>
+            </a:r>
+          </a:p>
+          <a:p>
+            <a:pPr lvl="0"/>
+            <a:r>
+              <a:rPr lang="en-US" sz="1200" dirty="0">
+                <a:solidFill>
+                  <a:schemeClr val="bg1"/>
+                </a:solidFill>
+              </a:rPr>
+              <a:t>That any variable that is not selected (true or not) will have its estimate treated as zero, which adds to bias and counts as non-coverage.</a:t>
             </a:r>
           </a:p>
           <a:p>
@@ -994,102 +1253,17 @@
           </a:p>
           <a:p>
             <a:r>
-              <a:rPr lang="en-US" dirty="0"/>
-              <a:t>We then fit a full model with all predictors and apply each variable selection method to identify a final set of variables.</a:t>
-            </a:r>
-            <a:br>
-              <a:rPr lang="en-US" dirty="0"/>
-            </a:br>
-            <a:endParaRPr lang="en-US" dirty="0"/>
-          </a:p>
-          <a:p>
-            <a:r>
-              <a:rPr lang="en-US" dirty="0"/>
-              <a:t>After that, we refit the model using only the selected variables so that we can evaluate inference, including confidence intervals and hypothesis tests.</a:t>
-            </a:r>
-            <a:br>
-              <a:rPr lang="en-US" dirty="0"/>
-            </a:br>
-            <a:endParaRPr lang="en-US" dirty="0"/>
-          </a:p>
-          <a:p>
-            <a:r>
-              <a:rPr lang="en-US" dirty="0"/>
-              <a:t>We then repeat this entire process 10,000 times for each scenario to obtain stable estimates of performance and then are summarized as averages across the</a:t>
-            </a:r>
-          </a:p>
-          <a:p>
-            <a:r>
-              <a:rPr lang="en-US" dirty="0"/>
-              <a:t>Simulation runs</a:t>
-            </a:r>
-          </a:p>
-          <a:p>
-            <a:endParaRPr lang="en-US" dirty="0"/>
-          </a:p>
-          <a:p>
-            <a:r>
-              <a:rPr lang="en-US" dirty="0"/>
-              <a:t>Once all simulations are complete, we will evaluate performance across several metrics.</a:t>
-            </a:r>
-          </a:p>
-          <a:p>
-            <a:endParaRPr lang="en-US" dirty="0"/>
-          </a:p>
-          <a:p>
-            <a:r>
-              <a:rPr lang="en-US" dirty="0"/>
-              <a:t>First, we  will look at variable selection performance — more specifically how often each method correctly identifies true predictors and how often it incorrectly selects null variables. As an additional metric we will look at the mean number of variables selected from each method to assess complexity</a:t>
-            </a:r>
-            <a:br>
-              <a:rPr lang="en-US" dirty="0"/>
-            </a:br>
-            <a:endParaRPr lang="en-US" dirty="0"/>
-          </a:p>
-          <a:p>
-            <a:r>
-              <a:rPr lang="en-US" dirty="0"/>
-              <a:t>Second, we will evaluate estimation by looking at bias, CI coverage, and type I and type II error rates.</a:t>
-            </a:r>
-          </a:p>
-          <a:p>
-            <a:endParaRPr lang="en-US" dirty="0"/>
-          </a:p>
-          <a:p>
-            <a:r>
-              <a:rPr lang="en-US" dirty="0"/>
-              <a:t>A key detail here is that these metrics are evaluated across all variables, not just those selected.</a:t>
-            </a:r>
-            <a:br>
-              <a:rPr lang="en-US" dirty="0"/>
-            </a:br>
-            <a:endParaRPr lang="en-US" dirty="0"/>
-          </a:p>
-          <a:p>
-            <a:r>
-              <a:rPr lang="en-US" dirty="0"/>
-              <a:t>So, if a method fails to select a true predictor, we treat its estimate as zero — which increases bias and counts as a failure for coverage.</a:t>
-            </a:r>
-            <a:br>
-              <a:rPr lang="en-US" dirty="0"/>
-            </a:br>
-            <a:endParaRPr lang="en-US" dirty="0"/>
-          </a:p>
-          <a:p>
-            <a:r>
-              <a:rPr lang="en-US" dirty="0"/>
-              <a:t>And finally to summarize these findings we will provide tables and plots similar to what </a:t>
-            </a:r>
-            <a:r>
-              <a:rPr lang="en-US" dirty="0" err="1"/>
-              <a:t>ive</a:t>
-            </a:r>
-            <a:r>
-              <a:rPr lang="en-US" dirty="0"/>
-              <a:t> shown here.</a:t>
-            </a:r>
-          </a:p>
-          <a:p>
+              <a:rPr lang="en-US" sz="1200" b="0" i="0" u="none" strike="noStrike" kern="1200" dirty="0">
+                <a:solidFill>
+                  <a:schemeClr val="tx1"/>
+                </a:solidFill>
+                <a:effectLst/>
+                <a:latin typeface="+mn-lt"/>
+                <a:ea typeface="+mn-ea"/>
+                <a:cs typeface="+mn-cs"/>
+              </a:rPr>
+              <a:t>Once all simulations are complete, results will be summarized using tables and plots like the examples shown here,</a:t>
+            </a:r>
             <a:endParaRPr lang="en-US" dirty="0"/>
           </a:p>
         </p:txBody>
@@ -1237,7 +1411,7 @@
           <a:p>
             <a:fld id="{C16525B2-4347-4F72-BAF7-76B19438D329}" type="datetimeFigureOut">
               <a:rPr lang="en-US" smtClean="0"/>
-              <a:t>5/1/26</a:t>
+              <a:t>5/4/26</a:t>
             </a:fld>
             <a:endParaRPr lang="en-US"/>
           </a:p>
@@ -1460,7 +1634,7 @@
           <a:p>
             <a:fld id="{1D8BD707-D9CF-40AE-B4C6-C98DA3205C09}" type="datetimeFigureOut">
               <a:rPr lang="en-US"/>
-              <a:t>5/1/26</a:t>
+              <a:t>5/4/26</a:t>
             </a:fld>
             <a:endParaRPr lang="en-US"/>
           </a:p>
@@ -1999,7 +2173,7 @@
                 <a:latin typeface="+mj-lt"/>
                 <a:cs typeface="WPQCJM+FranklinGothic-Book"/>
               </a:rPr>
-              <a:t> &amp; Simulation Design</a:t>
+              <a:t> / Aims</a:t>
             </a:r>
             <a:endParaRPr sz="4400" dirty="0">
               <a:solidFill>
@@ -2011,18 +2185,286 @@
           </a:p>
         </p:txBody>
       </p:sp>
-      <mc:AlternateContent xmlns:mc="http://schemas.openxmlformats.org/markup-compatibility/2006">
-        <mc:Choice xmlns:a14="http://schemas.microsoft.com/office/drawing/2010/main" Requires="a14">
+      <p:sp>
+        <p:nvSpPr>
+          <p:cNvPr id="4" name="object 4"/>
+          <p:cNvSpPr txBox="1"/>
+          <p:nvPr/>
+        </p:nvSpPr>
+        <p:spPr>
+          <a:xfrm>
+            <a:off x="1127448" y="1628800"/>
+            <a:ext cx="9265920" cy="3244478"/>
+          </a:xfrm>
+          <a:prstGeom prst="rect">
+            <a:avLst/>
+          </a:prstGeom>
+        </p:spPr>
+        <p:txBody>
+          <a:bodyPr vert="horz" wrap="square" lIns="0" tIns="0" rIns="0" bIns="0" rtlCol="0">
+            <a:spAutoFit/>
+          </a:bodyPr>
+          <a:lstStyle/>
+          <a:p>
+            <a:pPr marL="285750" indent="-285750">
+              <a:lnSpc>
+                <a:spcPts val="2258"/>
+              </a:lnSpc>
+              <a:buFont typeface="Wingdings" pitchFamily="2" charset="2"/>
+              <a:buChar char="q"/>
+            </a:pPr>
+            <a:r>
+              <a:rPr lang="en-US" sz="2000" dirty="0"/>
+              <a:t>How do different variable selection methods perform in including true predictors and excluding irrelevant predictors in linear regression models under varying sample sizes and levels of variable correlation</a:t>
+            </a:r>
+          </a:p>
+          <a:p>
+            <a:pPr>
+              <a:lnSpc>
+                <a:spcPts val="2258"/>
+              </a:lnSpc>
+            </a:pPr>
+            <a:endParaRPr lang="en-US" sz="2000" dirty="0"/>
+          </a:p>
+          <a:p>
+            <a:pPr>
+              <a:lnSpc>
+                <a:spcPts val="2258"/>
+              </a:lnSpc>
+            </a:pPr>
+            <a:endParaRPr lang="en-US" sz="2000" dirty="0">
+              <a:solidFill>
+                <a:srgbClr val="181A0D"/>
+              </a:solidFill>
+              <a:latin typeface="WPQCJM+FranklinGothic-Book"/>
+              <a:cs typeface="WPQCJM+FranklinGothic-Book"/>
+            </a:endParaRPr>
+          </a:p>
+          <a:p>
+            <a:pPr>
+              <a:lnSpc>
+                <a:spcPts val="2258"/>
+              </a:lnSpc>
+            </a:pPr>
+            <a:endParaRPr lang="en-US" sz="2000" dirty="0">
+              <a:solidFill>
+                <a:srgbClr val="181A0D"/>
+              </a:solidFill>
+              <a:latin typeface="WPQCJM+FranklinGothic-Book"/>
+              <a:cs typeface="WPQCJM+FranklinGothic-Book"/>
+            </a:endParaRPr>
+          </a:p>
+          <a:p>
+            <a:pPr>
+              <a:lnSpc>
+                <a:spcPts val="2258"/>
+              </a:lnSpc>
+            </a:pPr>
+            <a:r>
+              <a:rPr lang="en-US" sz="2400" b="1" dirty="0">
+                <a:solidFill>
+                  <a:srgbClr val="181A0D"/>
+                </a:solidFill>
+                <a:cs typeface="WPQCJM+FranklinGothic-Book"/>
+              </a:rPr>
+              <a:t>Aims:</a:t>
+            </a:r>
+          </a:p>
+          <a:p>
+            <a:pPr marL="800100" lvl="1" indent="-342900">
+              <a:lnSpc>
+                <a:spcPts val="2258"/>
+              </a:lnSpc>
+              <a:buFont typeface="Wingdings" pitchFamily="2" charset="2"/>
+              <a:buChar char="Ø"/>
+            </a:pPr>
+            <a:r>
+              <a:rPr lang="en-US" sz="2000" dirty="0">
+                <a:solidFill>
+                  <a:srgbClr val="181A0D"/>
+                </a:solidFill>
+                <a:cs typeface="WPQCJM+FranklinGothic-Book"/>
+              </a:rPr>
+              <a:t>Compare variable selection accuracy across selection methods</a:t>
+            </a:r>
+          </a:p>
+          <a:p>
+            <a:pPr marL="800100" lvl="1" indent="-342900">
+              <a:lnSpc>
+                <a:spcPts val="2258"/>
+              </a:lnSpc>
+              <a:buFont typeface="Wingdings" pitchFamily="2" charset="2"/>
+              <a:buChar char="Ø"/>
+            </a:pPr>
+            <a:r>
+              <a:rPr lang="en-US" sz="2000" dirty="0">
+                <a:solidFill>
+                  <a:srgbClr val="181A0D"/>
+                </a:solidFill>
+                <a:cs typeface="WPQCJM+FranklinGothic-Book"/>
+              </a:rPr>
+              <a:t>Evaluate coefficient estimation performance (bias, CI coverage)</a:t>
+            </a:r>
+          </a:p>
+          <a:p>
+            <a:pPr marL="800100" lvl="1" indent="-342900">
+              <a:lnSpc>
+                <a:spcPts val="2258"/>
+              </a:lnSpc>
+              <a:buFont typeface="Wingdings" pitchFamily="2" charset="2"/>
+              <a:buChar char="Ø"/>
+            </a:pPr>
+            <a:r>
+              <a:rPr lang="en-US" sz="2000" dirty="0">
+                <a:solidFill>
+                  <a:srgbClr val="181A0D"/>
+                </a:solidFill>
+                <a:cs typeface="WPQCJM+FranklinGothic-Book"/>
+              </a:rPr>
+              <a:t>Assess Type I &amp; II error post-model selection</a:t>
+            </a:r>
+          </a:p>
+          <a:p>
+            <a:pPr>
+              <a:lnSpc>
+                <a:spcPts val="2258"/>
+              </a:lnSpc>
+            </a:pPr>
+            <a:endParaRPr lang="en-US" sz="2000" dirty="0">
+              <a:solidFill>
+                <a:srgbClr val="181A0D"/>
+              </a:solidFill>
+              <a:cs typeface="WPQCJM+FranklinGothic-Book"/>
+            </a:endParaRPr>
+          </a:p>
+        </p:txBody>
+      </p:sp>
+    </p:spTree>
+  </p:cSld>
+  <p:clrMapOvr>
+    <a:masterClrMapping/>
+  </p:clrMapOvr>
+</p:sld>
+</file>
+
+<file path=ppt/slides/slide3.xml><?xml version="1.0" encoding="utf-8"?>
+<p:sld xmlns:a="http://schemas.openxmlformats.org/drawingml/2006/main" xmlns:r="http://schemas.openxmlformats.org/officeDocument/2006/relationships" xmlns:p="http://schemas.openxmlformats.org/presentationml/2006/main" showMasterSp="0">
+  <p:cSld>
+    <p:spTree>
+      <p:nvGrpSpPr>
+        <p:cNvPr id="1" name=""/>
+        <p:cNvGrpSpPr/>
+        <p:nvPr/>
+      </p:nvGrpSpPr>
+      <p:grpSpPr>
+        <a:xfrm>
+          <a:off x="0" y="0"/>
+          <a:ext cx="0" cy="0"/>
+          <a:chOff x="0" y="0"/>
+          <a:chExt cx="0" cy="0"/>
+        </a:xfrm>
+      </p:grpSpPr>
+      <p:sp>
+        <p:nvSpPr>
+          <p:cNvPr id="2" name="object 1"/>
+          <p:cNvSpPr/>
+          <p:nvPr/>
+        </p:nvSpPr>
+        <p:spPr>
+          <a:xfrm>
+            <a:off x="0" y="0"/>
+            <a:ext cx="12192000" cy="6858000"/>
+          </a:xfrm>
+          <a:prstGeom prst="rect">
+            <a:avLst/>
+          </a:prstGeom>
+          <a:blipFill>
+            <a:blip r:embed="rId3" cstate="print"/>
+            <a:stretch>
+              <a:fillRect/>
+            </a:stretch>
+          </a:blipFill>
+        </p:spPr>
+        <p:txBody>
+          <a:bodyPr wrap="square" lIns="0" tIns="0" rIns="0" bIns="0" rtlCol="0">
+            <a:spAutoFit/>
+          </a:bodyPr>
+          <a:lstStyle/>
+          <a:p>
+            <a:endParaRPr dirty="0"/>
+          </a:p>
+        </p:txBody>
+      </p:sp>
+      <p:sp>
+        <p:nvSpPr>
+          <p:cNvPr id="3" name="object 3"/>
+          <p:cNvSpPr txBox="1"/>
+          <p:nvPr/>
+        </p:nvSpPr>
+        <p:spPr>
+          <a:xfrm>
+            <a:off x="1055440" y="244403"/>
+            <a:ext cx="9433048" cy="641201"/>
+          </a:xfrm>
+          <a:prstGeom prst="rect">
+            <a:avLst/>
+          </a:prstGeom>
+        </p:spPr>
+        <p:txBody>
+          <a:bodyPr vert="horz" wrap="square" lIns="0" tIns="0" rIns="0" bIns="0" rtlCol="0">
+            <a:spAutoFit/>
+          </a:bodyPr>
+          <a:lstStyle/>
+          <a:p>
+            <a:pPr marL="0" marR="0">
+              <a:lnSpc>
+                <a:spcPts val="4979"/>
+              </a:lnSpc>
+              <a:spcBef>
+                <a:spcPts val="0"/>
+              </a:spcBef>
+              <a:spcAft>
+                <a:spcPts val="0"/>
+              </a:spcAft>
+            </a:pPr>
+            <a:r>
+              <a:rPr lang="en-US" sz="4400" dirty="0">
+                <a:solidFill>
+                  <a:srgbClr val="181A0D"/>
+                </a:solidFill>
+                <a:latin typeface="+mj-lt"/>
+                <a:cs typeface="VTCKGD+FranklinGothic-Book"/>
+              </a:rPr>
+              <a:t>Design &amp; Methods</a:t>
+            </a:r>
+            <a:endParaRPr sz="4400" dirty="0">
+              <a:solidFill>
+                <a:srgbClr val="181A0D"/>
+              </a:solidFill>
+              <a:latin typeface="+mj-lt"/>
+              <a:cs typeface="VTCKGD+FranklinGothic-Book"/>
+            </a:endParaRPr>
+          </a:p>
+        </p:txBody>
+      </p:sp>
+      <mc:AlternateContent xmlns:mc="http://schemas.openxmlformats.org/markup-compatibility/2006" xmlns:a14="http://schemas.microsoft.com/office/drawing/2010/main">
+        <mc:Choice Requires="a14">
           <p:sp>
             <p:nvSpPr>
-              <p:cNvPr id="4" name="object 4"/>
+              <p:cNvPr id="16" name="object 4">
+                <a:extLst>
+                  <a:ext uri="{FF2B5EF4-FFF2-40B4-BE49-F238E27FC236}">
+                    <a16:creationId xmlns:a16="http://schemas.microsoft.com/office/drawing/2014/main" id="{374F020B-F79C-7A71-C268-57FB6096B43E}"/>
+                  </a:ext>
+                </a:extLst>
+              </p:cNvPr>
               <p:cNvSpPr txBox="1"/>
               <p:nvPr/>
             </p:nvSpPr>
             <p:spPr>
               <a:xfrm>
-                <a:off x="1127448" y="1162497"/>
-                <a:ext cx="9265920" cy="5052665"/>
+                <a:off x="7824192" y="1130007"/>
+                <a:ext cx="4104456" cy="4732065"/>
               </a:xfrm>
               <a:prstGeom prst="rect">
                 <a:avLst/>
@@ -2034,29 +2476,15 @@
               </a:bodyPr>
               <a:lstStyle/>
               <a:p>
-                <a:pPr marL="285750" indent="-285750">
-                  <a:lnSpc>
-                    <a:spcPts val="2258"/>
-                  </a:lnSpc>
-                  <a:buFont typeface="Wingdings" pitchFamily="2" charset="2"/>
-                  <a:buChar char="q"/>
-                </a:pPr>
-                <a:r>
-                  <a:rPr lang="en-US" sz="2000" dirty="0"/>
-                  <a:t>How do different variable selection methods perform in including true predictors and excluding irrelevant predictors in linear regression models under varying sample sizes and levels of variable correlation</a:t>
-                </a:r>
-              </a:p>
-              <a:p>
                 <a:pPr>
                   <a:lnSpc>
                     <a:spcPts val="2258"/>
                   </a:lnSpc>
                 </a:pPr>
-                <a:endParaRPr lang="en-US" sz="2000" dirty="0">
+                <a:endParaRPr lang="en-US" sz="2400" b="1" dirty="0">
                   <a:solidFill>
                     <a:srgbClr val="181A0D"/>
                   </a:solidFill>
-                  <a:latin typeface="WPQCJM+FranklinGothic-Book"/>
                   <a:cs typeface="WPQCJM+FranklinGothic-Book"/>
                 </a:endParaRPr>
               </a:p>
@@ -2073,7 +2501,7 @@
                     </a:solidFill>
                     <a:cs typeface="WPQCJM+FranklinGothic-Book"/>
                   </a:rPr>
-                  <a:t>Aims:</a:t>
+                  <a:t>Backward Selection:</a:t>
                 </a:r>
               </a:p>
               <a:p>
@@ -2091,7 +2519,7 @@
                     </a:solidFill>
                     <a:cs typeface="WPQCJM+FranklinGothic-Book"/>
                   </a:rPr>
-                  <a:t>Compare variable selection accuracy across selection methods</a:t>
+                  <a:t>P-value/F-test (α=0.157)</a:t>
                 </a:r>
               </a:p>
               <a:p>
@@ -2109,7 +2537,7 @@
                     </a:solidFill>
                     <a:cs typeface="WPQCJM+FranklinGothic-Book"/>
                   </a:rPr>
-                  <a:t>Evaluate coefficient estimation performance (bias, CI coverage)</a:t>
+                  <a:t>AIC (MASS package)</a:t>
                 </a:r>
               </a:p>
               <a:p>
@@ -2127,8 +2555,357 @@
                     </a:solidFill>
                     <a:cs typeface="WPQCJM+FranklinGothic-Book"/>
                   </a:rPr>
-                  <a:t>Assess Type I &amp; II error post-model selection</a:t>
+                  <a:t>BIC (</a:t>
                 </a:r>
+                <a:r>
+                  <a:rPr lang="en-US" sz="2000" dirty="0"/>
+                  <a:t>MASS package)</a:t>
+                </a:r>
+              </a:p>
+              <a:p>
+                <a:pPr marL="800100" lvl="1" indent="-342900">
+                  <a:lnSpc>
+                    <a:spcPts val="2258"/>
+                  </a:lnSpc>
+                  <a:buFont typeface="Wingdings" pitchFamily="2" charset="2"/>
+                  <a:buChar char="Ø"/>
+                </a:pPr>
+                <a:endParaRPr lang="en-US" sz="2000" dirty="0">
+                  <a:solidFill>
+                    <a:srgbClr val="181A0D"/>
+                  </a:solidFill>
+                  <a:cs typeface="WPQCJM+FranklinGothic-Book"/>
+                </a:endParaRPr>
+              </a:p>
+              <a:p>
+                <a:pPr lvl="1">
+                  <a:lnSpc>
+                    <a:spcPts val="2258"/>
+                  </a:lnSpc>
+                </a:pPr>
+                <a:endParaRPr lang="en-US" sz="2000" dirty="0">
+                  <a:solidFill>
+                    <a:srgbClr val="181A0D"/>
+                  </a:solidFill>
+                  <a:cs typeface="WPQCJM+FranklinGothic-Book"/>
+                </a:endParaRPr>
+              </a:p>
+              <a:p>
+                <a:pPr>
+                  <a:lnSpc>
+                    <a:spcPts val="2258"/>
+                  </a:lnSpc>
+                </a:pPr>
+                <a:r>
+                  <a:rPr lang="en-US" sz="2400" b="1" dirty="0">
+                    <a:solidFill>
+                      <a:srgbClr val="181A0D"/>
+                    </a:solidFill>
+                    <a:cs typeface="WPQCJM+FranklinGothic-Book"/>
+                  </a:rPr>
+                  <a:t>Penalized Regression:</a:t>
+                </a:r>
+              </a:p>
+              <a:p>
+                <a:pPr marL="800100" lvl="1" indent="-342900">
+                  <a:lnSpc>
+                    <a:spcPts val="2258"/>
+                  </a:lnSpc>
+                  <a:buFont typeface="Wingdings" pitchFamily="2" charset="2"/>
+                  <a:buChar char="Ø"/>
+                </a:pPr>
+                <a:r>
+                  <a:rPr lang="en-US" sz="2000" dirty="0">
+                    <a:solidFill>
+                      <a:srgbClr val="181A0D"/>
+                    </a:solidFill>
+                    <a:cs typeface="WPQCJM+FranklinGothic-Book"/>
+                  </a:rPr>
+                  <a:t>LASSO (</a:t>
+                </a:r>
+                <a14:m>
+                  <m:oMath xmlns:m="http://schemas.openxmlformats.org/officeDocument/2006/math">
+                    <m:sSub>
+                      <m:sSubPr>
+                        <m:ctrlPr>
+                          <a:rPr lang="ar-AE" sz="2000" i="1" smtClean="0">
+                            <a:latin typeface="Cambria Math" panose="02040503050406030204" pitchFamily="18" charset="0"/>
+                          </a:rPr>
+                        </m:ctrlPr>
+                      </m:sSubPr>
+                      <m:e>
+                        <m:r>
+                          <a:rPr lang="ar-AE" sz="2000" i="1">
+                            <a:latin typeface="Cambria Math" panose="02040503050406030204" pitchFamily="18" charset="0"/>
+                          </a:rPr>
+                          <m:t>𝐿</m:t>
+                        </m:r>
+                      </m:e>
+                      <m:sub>
+                        <m:r>
+                          <a:rPr lang="ar-AE" sz="2000" i="1">
+                            <a:latin typeface="Cambria Math" panose="02040503050406030204" pitchFamily="18" charset="0"/>
+                          </a:rPr>
+                          <m:t>1</m:t>
+                        </m:r>
+                      </m:sub>
+                    </m:sSub>
+                    <m:r>
+                      <a:rPr lang="en-US" sz="2000" b="0" i="0" smtClean="0">
+                        <a:latin typeface="Cambria Math" panose="02040503050406030204" pitchFamily="18" charset="0"/>
+                      </a:rPr>
+                      <m:t>)</m:t>
+                    </m:r>
+                  </m:oMath>
+                </a14:m>
+                <a:endParaRPr lang="ar-AE" sz="2000" dirty="0">
+                  <a:solidFill>
+                    <a:srgbClr val="181A0D"/>
+                  </a:solidFill>
+                  <a:cs typeface="WPQCJM+FranklinGothic-Book"/>
+                </a:endParaRPr>
+              </a:p>
+              <a:p>
+                <a:pPr marL="800100" lvl="1" indent="-342900">
+                  <a:lnSpc>
+                    <a:spcPts val="2258"/>
+                  </a:lnSpc>
+                  <a:buFont typeface="Wingdings" pitchFamily="2" charset="2"/>
+                  <a:buChar char="Ø"/>
+                </a:pPr>
+                <a:r>
+                  <a:rPr lang="en-US" sz="2000" dirty="0">
+                    <a:solidFill>
+                      <a:srgbClr val="181A0D"/>
+                    </a:solidFill>
+                    <a:cs typeface="WPQCJM+FranklinGothic-Book"/>
+                  </a:rPr>
+                  <a:t>Elastic Net (</a:t>
+                </a:r>
+                <a14:m>
+                  <m:oMath xmlns:m="http://schemas.openxmlformats.org/officeDocument/2006/math">
+                    <m:sSub>
+                      <m:sSubPr>
+                        <m:ctrlPr>
+                          <a:rPr lang="ar-AE" sz="2000" i="1">
+                            <a:latin typeface="Cambria Math" panose="02040503050406030204" pitchFamily="18" charset="0"/>
+                          </a:rPr>
+                        </m:ctrlPr>
+                      </m:sSubPr>
+                      <m:e>
+                        <m:r>
+                          <a:rPr lang="ar-AE" sz="2000" i="1">
+                            <a:latin typeface="Cambria Math" panose="02040503050406030204" pitchFamily="18" charset="0"/>
+                          </a:rPr>
+                          <m:t>𝐿</m:t>
+                        </m:r>
+                      </m:e>
+                      <m:sub>
+                        <m:r>
+                          <a:rPr lang="ar-AE" sz="2000" i="1">
+                            <a:latin typeface="Cambria Math" panose="02040503050406030204" pitchFamily="18" charset="0"/>
+                          </a:rPr>
+                          <m:t>1</m:t>
+                        </m:r>
+                      </m:sub>
+                    </m:sSub>
+                  </m:oMath>
+                </a14:m>
+                <a:r>
+                  <a:rPr lang="ar-AE" sz="2000" dirty="0"/>
+                  <a:t> +  </a:t>
+                </a:r>
+                <a14:m>
+                  <m:oMath xmlns:m="http://schemas.openxmlformats.org/officeDocument/2006/math">
+                    <m:sSub>
+                      <m:sSubPr>
+                        <m:ctrlPr>
+                          <a:rPr lang="ar-AE" sz="2000" i="1">
+                            <a:latin typeface="Cambria Math" panose="02040503050406030204" pitchFamily="18" charset="0"/>
+                          </a:rPr>
+                        </m:ctrlPr>
+                      </m:sSubPr>
+                      <m:e>
+                        <m:r>
+                          <a:rPr lang="ar-AE" sz="2000" i="1">
+                            <a:latin typeface="Cambria Math" panose="02040503050406030204" pitchFamily="18" charset="0"/>
+                          </a:rPr>
+                          <m:t>𝐿</m:t>
+                        </m:r>
+                      </m:e>
+                      <m:sub>
+                        <m:r>
+                          <a:rPr lang="ar-AE" sz="2000" i="1">
+                            <a:latin typeface="Cambria Math" panose="02040503050406030204" pitchFamily="18" charset="0"/>
+                          </a:rPr>
+                          <m:t>2</m:t>
+                        </m:r>
+                      </m:sub>
+                    </m:sSub>
+                  </m:oMath>
+                </a14:m>
+                <a:r>
+                  <a:rPr lang="ar-AE" sz="2000" dirty="0"/>
+                  <a:t> , </a:t>
+                </a:r>
+                <a:r>
+                  <a:rPr lang="el-GR" sz="2000" dirty="0"/>
+                  <a:t>α</a:t>
+                </a:r>
+                <a:r>
+                  <a:rPr lang="en-US" sz="2000" dirty="0"/>
+                  <a:t>=0.5</a:t>
+                </a:r>
+                <a:r>
+                  <a:rPr lang="el-GR" sz="2000" dirty="0"/>
+                  <a:t>)</a:t>
+                </a:r>
+              </a:p>
+              <a:p>
+                <a:pPr marL="800100" lvl="1" indent="-342900">
+                  <a:lnSpc>
+                    <a:spcPts val="2258"/>
+                  </a:lnSpc>
+                  <a:buFont typeface="Wingdings" pitchFamily="2" charset="2"/>
+                  <a:buChar char="Ø"/>
+                </a:pPr>
+                <a:r>
+                  <a:rPr lang="el-GR" sz="2000" dirty="0">
+                    <a:solidFill>
+                      <a:srgbClr val="181A0D"/>
+                    </a:solidFill>
+                    <a:cs typeface="WPQCJM+FranklinGothic-Book"/>
+                  </a:rPr>
+                  <a:t>λ </a:t>
+                </a:r>
+                <a:r>
+                  <a:rPr lang="en-US" sz="2000" dirty="0">
+                    <a:solidFill>
+                      <a:srgbClr val="181A0D"/>
+                    </a:solidFill>
+                    <a:cs typeface="WPQCJM+FranklinGothic-Book"/>
+                  </a:rPr>
+                  <a:t>selected via 10-fold CV</a:t>
+                </a:r>
+              </a:p>
+              <a:p>
+                <a:pPr marL="1257300" lvl="2" indent="-342900">
+                  <a:lnSpc>
+                    <a:spcPts val="2258"/>
+                  </a:lnSpc>
+                  <a:buFont typeface="Wingdings" pitchFamily="2" charset="2"/>
+                  <a:buChar char="§"/>
+                </a:pPr>
+                <a14:m>
+                  <m:oMath xmlns:m="http://schemas.openxmlformats.org/officeDocument/2006/math">
+                    <m:sSub>
+                      <m:sSubPr>
+                        <m:ctrlPr>
+                          <a:rPr lang="ar-AE" sz="2000" i="1">
+                            <a:latin typeface="Cambria Math" panose="02040503050406030204" pitchFamily="18" charset="0"/>
+                          </a:rPr>
+                        </m:ctrlPr>
+                      </m:sSubPr>
+                      <m:e>
+                        <m:r>
+                          <a:rPr lang="ar-AE" sz="2000" b="0" i="1">
+                            <a:latin typeface="Cambria Math" panose="02040503050406030204" pitchFamily="18" charset="0"/>
+                          </a:rPr>
+                          <m:t>𝜆</m:t>
+                        </m:r>
+                      </m:e>
+                      <m:sub>
+                        <m:r>
+                          <a:rPr lang="ar-AE" sz="2000" b="0" i="1">
+                            <a:latin typeface="Cambria Math" panose="02040503050406030204" pitchFamily="18" charset="0"/>
+                          </a:rPr>
+                          <m:t>𝑚𝑖𝑛</m:t>
+                        </m:r>
+                      </m:sub>
+                    </m:sSub>
+                  </m:oMath>
+                </a14:m>
+                <a:r>
+                  <a:rPr lang="ar-AE" sz="2000" dirty="0"/>
+                  <a:t>  </a:t>
+                </a:r>
+                <a:endParaRPr lang="en-US" sz="2000" dirty="0"/>
+              </a:p>
+              <a:p>
+                <a:pPr marL="1257300" lvl="2" indent="-342900">
+                  <a:lnSpc>
+                    <a:spcPts val="2258"/>
+                  </a:lnSpc>
+                  <a:buFont typeface="Wingdings" pitchFamily="2" charset="2"/>
+                  <a:buChar char="§"/>
+                </a:pPr>
+                <a14:m>
+                  <m:oMath xmlns:m="http://schemas.openxmlformats.org/officeDocument/2006/math">
+                    <m:sSub>
+                      <m:sSubPr>
+                        <m:ctrlPr>
+                          <a:rPr lang="ar-AE" sz="2000" i="1">
+                            <a:latin typeface="Cambria Math" panose="02040503050406030204" pitchFamily="18" charset="0"/>
+                          </a:rPr>
+                        </m:ctrlPr>
+                      </m:sSubPr>
+                      <m:e>
+                        <m:r>
+                          <a:rPr lang="ar-AE" sz="2000" i="1">
+                            <a:latin typeface="Cambria Math" panose="02040503050406030204" pitchFamily="18" charset="0"/>
+                          </a:rPr>
+                          <m:t>𝜆</m:t>
+                        </m:r>
+                      </m:e>
+                      <m:sub>
+                        <m:r>
+                          <a:rPr lang="ar-AE" sz="2000" i="1">
+                            <a:latin typeface="Cambria Math" panose="02040503050406030204" pitchFamily="18" charset="0"/>
+                          </a:rPr>
+                          <m:t>1</m:t>
+                        </m:r>
+                        <m:r>
+                          <a:rPr lang="ar-AE" sz="2000" i="1">
+                            <a:latin typeface="Cambria Math" panose="02040503050406030204" pitchFamily="18" charset="0"/>
+                          </a:rPr>
+                          <m:t>𝑠𝑒</m:t>
+                        </m:r>
+                      </m:sub>
+                    </m:sSub>
+                  </m:oMath>
+                </a14:m>
+                <a:endParaRPr lang="ar-AE" sz="2000" dirty="0">
+                  <a:solidFill>
+                    <a:srgbClr val="181A0D"/>
+                  </a:solidFill>
+                  <a:cs typeface="WPQCJM+FranklinGothic-Book"/>
+                </a:endParaRPr>
+              </a:p>
+              <a:p>
+                <a:pPr lvl="1">
+                  <a:lnSpc>
+                    <a:spcPts val="2258"/>
+                  </a:lnSpc>
+                </a:pPr>
+                <a:endParaRPr lang="en-US" sz="2000" dirty="0">
+                  <a:solidFill>
+                    <a:srgbClr val="181A0D"/>
+                  </a:solidFill>
+                  <a:cs typeface="WPQCJM+FranklinGothic-Book"/>
+                </a:endParaRPr>
+              </a:p>
+              <a:p>
+                <a:pPr lvl="1">
+                  <a:lnSpc>
+                    <a:spcPts val="2258"/>
+                  </a:lnSpc>
+                </a:pPr>
+                <a:endParaRPr lang="en-US" sz="2000" dirty="0">
+                  <a:solidFill>
+                    <a:srgbClr val="181A0D"/>
+                  </a:solidFill>
+                  <a:cs typeface="WPQCJM+FranklinGothic-Book"/>
+                </a:endParaRPr>
               </a:p>
               <a:p>
                 <a:pPr>
@@ -2143,6 +2920,83 @@
                   <a:cs typeface="WPQCJM+FranklinGothic-Book"/>
                 </a:endParaRPr>
               </a:p>
+            </p:txBody>
+          </p:sp>
+        </mc:Choice>
+        <mc:Fallback xmlns="">
+          <p:sp>
+            <p:nvSpPr>
+              <p:cNvPr id="16" name="object 4">
+                <a:extLst>
+                  <a:ext uri="{FF2B5EF4-FFF2-40B4-BE49-F238E27FC236}">
+                    <a16:creationId xmlns:a16="http://schemas.microsoft.com/office/drawing/2014/main" id="{374F020B-F79C-7A71-C268-57FB6096B43E}"/>
+                  </a:ext>
+                </a:extLst>
+              </p:cNvPr>
+              <p:cNvSpPr txBox="1">
+                <a:spLocks noRot="1" noChangeAspect="1" noMove="1" noResize="1" noEditPoints="1" noAdjustHandles="1" noChangeArrowheads="1" noChangeShapeType="1" noTextEdit="1"/>
+              </p:cNvSpPr>
+              <p:nvPr/>
+            </p:nvSpPr>
+            <p:spPr>
+              <a:xfrm>
+                <a:off x="7824192" y="1130007"/>
+                <a:ext cx="4104456" cy="4732065"/>
+              </a:xfrm>
+              <a:prstGeom prst="rect">
+                <a:avLst/>
+              </a:prstGeom>
+              <a:blipFill>
+                <a:blip r:embed="rId4"/>
+                <a:stretch>
+                  <a:fillRect l="-4308"/>
+                </a:stretch>
+              </a:blipFill>
+            </p:spPr>
+            <p:txBody>
+              <a:bodyPr/>
+              <a:lstStyle/>
+              <a:p>
+                <a:r>
+                  <a:rPr lang="en-US">
+                    <a:noFill/>
+                  </a:rPr>
+                  <a:t> </a:t>
+                </a:r>
+              </a:p>
+            </p:txBody>
+          </p:sp>
+        </mc:Fallback>
+      </mc:AlternateContent>
+      <mc:AlternateContent xmlns:mc="http://schemas.openxmlformats.org/markup-compatibility/2006" xmlns:a14="http://schemas.microsoft.com/office/drawing/2010/main">
+        <mc:Choice Requires="a14">
+          <p:sp>
+            <p:nvSpPr>
+              <p:cNvPr id="4" name="TextBox 3">
+                <a:extLst>
+                  <a:ext uri="{FF2B5EF4-FFF2-40B4-BE49-F238E27FC236}">
+                    <a16:creationId xmlns:a16="http://schemas.microsoft.com/office/drawing/2014/main" id="{617ECB50-2355-E827-B570-C880457499B5}"/>
+                  </a:ext>
+                </a:extLst>
+              </p:cNvPr>
+              <p:cNvSpPr txBox="1"/>
+              <p:nvPr/>
+            </p:nvSpPr>
+            <p:spPr>
+              <a:xfrm>
+                <a:off x="761425" y="1416279"/>
+                <a:ext cx="6064999" cy="3947234"/>
+              </a:xfrm>
+              <a:prstGeom prst="rect">
+                <a:avLst/>
+              </a:prstGeom>
+              <a:noFill/>
+            </p:spPr>
+            <p:txBody>
+              <a:bodyPr wrap="square" rtlCol="0">
+                <a:spAutoFit/>
+              </a:bodyPr>
+              <a:lstStyle/>
               <a:p>
                 <a:pPr>
                   <a:lnSpc>
@@ -2173,7 +3027,39 @@
                       <a:srgbClr val="181A0D"/>
                     </a:solidFill>
                   </a:rPr>
-                  <a:t>Data generated using hdrm::gen_data() under Linear Regression</a:t>
+                  <a:t>Data generated under Linear Regression using </a:t>
+                </a:r>
+                <a:r>
+                  <a:rPr lang="en-US" sz="2000" dirty="0" err="1">
+                    <a:solidFill>
+                      <a:srgbClr val="181A0D"/>
+                    </a:solidFill>
+                  </a:rPr>
+                  <a:t>hdrm</a:t>
+                </a:r>
+                <a:r>
+                  <a:rPr lang="en-US" sz="2000" dirty="0">
+                    <a:solidFill>
+                      <a:srgbClr val="181A0D"/>
+                    </a:solidFill>
+                  </a:rPr>
+                  <a:t>::</a:t>
+                </a:r>
+                <a:r>
+                  <a:rPr lang="en-US" sz="2000" dirty="0" err="1">
+                    <a:solidFill>
+                      <a:srgbClr val="181A0D"/>
+                    </a:solidFill>
+                  </a:rPr>
+                  <a:t>gen_data</a:t>
+                </a:r>
+                <a:r>
+                  <a:rPr lang="en-US" sz="2000" dirty="0">
+                    <a:solidFill>
+                      <a:srgbClr val="181A0D"/>
+                    </a:solidFill>
+                  </a:rPr>
+                  <a:t>() </a:t>
                 </a:r>
               </a:p>
               <a:p>
@@ -2226,8 +3112,17 @@
                 </a14:m>
                 <a:r>
                   <a:rPr lang="en-US" sz="2000" dirty="0"/>
-                  <a:t> ;  </a:t>
+                  <a:t> </a:t>
                 </a:r>
+              </a:p>
+              <a:p>
+                <a:pPr marL="1257300" lvl="2" indent="-342900">
+                  <a:lnSpc>
+                    <a:spcPts val="2258"/>
+                  </a:lnSpc>
+                  <a:buFont typeface="Wingdings" pitchFamily="2" charset="2"/>
+                  <a:buChar char="§"/>
+                </a:pPr>
                 <a14:m>
                   <m:oMath xmlns:m="http://schemas.openxmlformats.org/officeDocument/2006/math">
                     <m:r>
@@ -2285,10 +3180,25 @@
                       </m:sub>
                     </m:sSub>
                     <m:r>
+                      <a:rPr lang="en-US" sz="2000" b="0" i="0" smtClean="0">
+                        <a:solidFill>
+                          <a:srgbClr val="181A0D"/>
+                        </a:solidFill>
+                        <a:latin typeface="Cambria Math" panose="02040503050406030204" pitchFamily="18" charset="0"/>
+                      </a:rPr>
+                      <m:t> </m:t>
+                    </m:r>
+                    <m:r>
                       <a:rPr lang="en-US" sz="2000">
                         <a:latin typeface="Cambria Math" panose="02040503050406030204" pitchFamily="18" charset="0"/>
                       </a:rPr>
                       <m:t>×</m:t>
+                    </m:r>
+                    <m:r>
+                      <a:rPr lang="en-US" sz="2000" b="0" i="1" smtClean="0">
+                        <a:latin typeface="Cambria Math" panose="02040503050406030204" pitchFamily="18" charset="0"/>
+                      </a:rPr>
+                      <m:t> </m:t>
                     </m:r>
                     <m:r>
                       <a:rPr lang="en-US" sz="2000" i="1">
@@ -2300,19 +3210,7 @@
                       <a:rPr lang="en-US" sz="2000" b="0" i="1" smtClean="0">
                         <a:latin typeface="Cambria Math" panose="02040503050406030204" pitchFamily="18" charset="0"/>
                       </a:rPr>
-                      <m:t> </m:t>
-                    </m:r>
-                    <m:r>
-                      <a:rPr lang="en-US" sz="2000" b="0" i="0" smtClean="0">
-                        <a:latin typeface="Cambria Math" panose="02040503050406030204" pitchFamily="18" charset="0"/>
-                      </a:rPr>
-                      <m:t>;</m:t>
-                    </m:r>
-                    <m:r>
-                      <a:rPr lang="en-US" sz="2000" b="0" i="1" smtClean="0">
-                        <a:latin typeface="Cambria Math" panose="02040503050406030204" pitchFamily="18" charset="0"/>
-                      </a:rPr>
-                      <m:t> </m:t>
+                      <m:t> ; </m:t>
                     </m:r>
                     <m:r>
                       <a:rPr lang="en-US" sz="2000" i="1">
@@ -2400,16 +3298,44 @@
                     </a:solidFill>
                     <a:cs typeface="WPQCJM+FranklinGothic-Book"/>
                   </a:rPr>
-                  <a:t>5 true predictors: </a:t>
+                  <a:t>5 true predictors:</a:t>
                 </a:r>
+              </a:p>
+              <a:p>
+                <a:pPr marL="1714500" lvl="3" indent="-342900">
+                  <a:lnSpc>
+                    <a:spcPts val="2258"/>
+                  </a:lnSpc>
+                  <a:buFont typeface="Arial" panose="020B0604020202020204" pitchFamily="34" charset="0"/>
+                  <a:buChar char="•"/>
+                </a:pPr>
                 <a14:m>
                   <m:oMath xmlns:m="http://schemas.openxmlformats.org/officeDocument/2006/math">
-                    <m:r>
-                      <a:rPr lang="en-US" sz="2000" i="1">
-                        <a:latin typeface="Cambria Math" panose="02040503050406030204" pitchFamily="18" charset="0"/>
-                      </a:rPr>
-                      <m:t>𝛽</m:t>
-                    </m:r>
+                    <m:sSub>
+                      <m:sSubPr>
+                        <m:ctrlPr>
+                          <a:rPr lang="en-US" sz="2000" i="1" smtClean="0">
+                            <a:latin typeface="Cambria Math" panose="02040503050406030204" pitchFamily="18" charset="0"/>
+                          </a:rPr>
+                        </m:ctrlPr>
+                      </m:sSubPr>
+                      <m:e>
+                        <m:r>
+                          <a:rPr lang="en-US" sz="2000" i="1">
+                            <a:latin typeface="Cambria Math" panose="02040503050406030204" pitchFamily="18" charset="0"/>
+                          </a:rPr>
+                          <m:t>𝛽</m:t>
+                        </m:r>
+                      </m:e>
+                      <m:sub>
+                        <m:r>
+                          <a:rPr lang="en-US" sz="2000" b="0" i="1" smtClean="0">
+                            <a:latin typeface="Cambria Math" panose="02040503050406030204" pitchFamily="18" charset="0"/>
+                          </a:rPr>
+                          <m:t>1:5</m:t>
+                        </m:r>
+                      </m:sub>
+                    </m:sSub>
                     <m:r>
                       <a:rPr lang="en-US" sz="2000">
                         <a:latin typeface="Cambria Math" panose="02040503050406030204" pitchFamily="18" charset="0"/>
@@ -2420,7 +3346,7 @@
                       <m:rPr>
                         <m:nor/>
                       </m:rPr>
-                      <a:rPr lang="en-US" sz="2000" b="0" i="0" smtClean="0">
+                      <a:rPr lang="en-US" sz="2000">
                         <a:latin typeface="Cambria Math" panose="02040503050406030204" pitchFamily="18" charset="0"/>
                       </a:rPr>
                       <m:t>(</m:t>
@@ -2430,21 +3356,7 @@
                         <m:nor/>
                       </m:rPr>
                       <a:rPr lang="en-US" sz="2000"/>
-                      <m:t>0.5/3</m:t>
-                    </m:r>
-                    <m:r>
-                      <m:rPr>
-                        <m:nor/>
-                      </m:rPr>
-                      <a:rPr lang="en-US" sz="2000" b="0" i="0" smtClean="0"/>
-                      <m:t>, 1/3, 1.5/3, 2/3,</m:t>
-                    </m:r>
-                    <m:r>
-                      <m:rPr>
-                        <m:nor/>
-                      </m:rPr>
-                      <a:rPr lang="en-US" sz="2000"/>
-                      <m:t> 2.5/3</m:t>
+                      <m:t>0.5/3, 1/3, 1.5/3, 2/3, 2.5/3</m:t>
                     </m:r>
                   </m:oMath>
                 </a14:m>
@@ -2479,14 +3391,57 @@
                   <a:rPr lang="en-US" sz="2000" dirty="0"/>
                   <a:t> </a:t>
                 </a:r>
+                <a:endParaRPr lang="en-US" sz="2000" i="1" dirty="0">
+                  <a:latin typeface="Cambria Math" panose="02040503050406030204" pitchFamily="18" charset="0"/>
+                </a:endParaRPr>
+              </a:p>
+              <a:p>
+                <a:pPr marL="1714500" lvl="3" indent="-342900">
+                  <a:lnSpc>
+                    <a:spcPts val="2258"/>
+                  </a:lnSpc>
+                  <a:buFont typeface="Arial" panose="020B0604020202020204" pitchFamily="34" charset="0"/>
+                  <a:buChar char="•"/>
+                </a:pPr>
                 <a14:m>
                   <m:oMath xmlns:m="http://schemas.openxmlformats.org/officeDocument/2006/math">
-                    <m:r>
-                      <a:rPr lang="en-US" sz="2000" i="1">
-                        <a:latin typeface="Cambria Math" panose="02040503050406030204" pitchFamily="18" charset="0"/>
-                      </a:rPr>
-                      <m:t>𝛽</m:t>
-                    </m:r>
+                    <m:sSub>
+                      <m:sSubPr>
+                        <m:ctrlPr>
+                          <a:rPr lang="en-US" sz="2000" i="1">
+                            <a:latin typeface="Cambria Math" panose="02040503050406030204" pitchFamily="18" charset="0"/>
+                          </a:rPr>
+                        </m:ctrlPr>
+                      </m:sSubPr>
+                      <m:e>
+                        <m:r>
+                          <a:rPr lang="en-US" sz="2000" i="1">
+                            <a:latin typeface="Cambria Math" panose="02040503050406030204" pitchFamily="18" charset="0"/>
+                          </a:rPr>
+                          <m:t>𝛽</m:t>
+                        </m:r>
+                      </m:e>
+                      <m:sub>
+                        <m:r>
+                          <a:rPr lang="en-US" sz="2000" b="0" i="1" smtClean="0">
+                            <a:latin typeface="Cambria Math" panose="02040503050406030204" pitchFamily="18" charset="0"/>
+                          </a:rPr>
+                          <m:t>6</m:t>
+                        </m:r>
+                        <m:r>
+                          <a:rPr lang="en-US" sz="2000" i="1">
+                            <a:latin typeface="Cambria Math" panose="02040503050406030204" pitchFamily="18" charset="0"/>
+                          </a:rPr>
+                          <m:t>:</m:t>
+                        </m:r>
+                        <m:r>
+                          <a:rPr lang="en-US" sz="2000" b="0" i="1" smtClean="0">
+                            <a:latin typeface="Cambria Math" panose="02040503050406030204" pitchFamily="18" charset="0"/>
+                          </a:rPr>
+                          <m:t>20</m:t>
+                        </m:r>
+                      </m:sub>
+                    </m:sSub>
                     <m:r>
                       <a:rPr lang="en-US" sz="2000">
                         <a:latin typeface="Cambria Math" panose="02040503050406030204" pitchFamily="18" charset="0"/>
@@ -2497,7 +3452,7 @@
                       <m:rPr>
                         <m:nor/>
                       </m:rPr>
-                      <a:rPr lang="en-US" sz="2000" b="0" i="0" smtClean="0">
+                      <a:rPr lang="en-US" sz="2000">
                         <a:latin typeface="Cambria Math" panose="02040503050406030204" pitchFamily="18" charset="0"/>
                       </a:rPr>
                       <m:t>0</m:t>
@@ -2530,7 +3485,7 @@
                     <m:sSub>
                       <m:sSubPr>
                         <m:ctrlPr>
-                          <a:rPr lang="en-US" sz="2000" i="1" smtClean="0">
+                          <a:rPr lang="en-US" sz="2000" i="1">
                             <a:solidFill>
                               <a:srgbClr val="181A0D"/>
                             </a:solidFill>
@@ -2543,7 +3498,7 @@
                           <m:rPr>
                             <m:sty m:val="p"/>
                           </m:rPr>
-                          <a:rPr lang="en-US" sz="2000" b="0" i="1" smtClean="0">
+                          <a:rPr lang="en-US" sz="2000" i="1">
                             <a:solidFill>
                               <a:srgbClr val="181A0D"/>
                             </a:solidFill>
@@ -2557,7 +3512,7 @@
                           <m:rPr>
                             <m:sty m:val="p"/>
                           </m:rPr>
-                          <a:rPr lang="en-US" sz="2000" b="0" i="1" smtClean="0">
+                          <a:rPr lang="en-US" sz="2000" i="1">
                             <a:solidFill>
                               <a:srgbClr val="181A0D"/>
                             </a:solidFill>
@@ -2570,13 +3525,8 @@
                   </m:oMath>
                 </a14:m>
                 <a:r>
-                  <a:rPr lang="en-US" sz="2000" dirty="0">
-                    <a:solidFill>
-                      <a:srgbClr val="181A0D"/>
-                    </a:solidFill>
-                    <a:cs typeface="WPQCJM+FranklinGothic-Book"/>
-                  </a:rPr>
-                  <a:t>=250 &amp; 500</a:t>
+                  <a:rPr lang="en-US" sz="2000" dirty="0"/>
+                  <a:t>∈ {250, 500}</a:t>
                 </a:r>
               </a:p>
               <a:p>
@@ -2596,7 +3546,7 @@
                 <a14:m>
                   <m:oMath xmlns:m="http://schemas.openxmlformats.org/officeDocument/2006/math">
                     <m:r>
-                      <a:rPr lang="en-US" sz="2000" i="1" smtClean="0">
+                      <a:rPr lang="en-US" sz="2000" i="1">
                         <a:solidFill>
                           <a:srgbClr val="181A0D"/>
                         </a:solidFill>
@@ -2615,7 +3565,20 @@
                     </a:solidFill>
                     <a:cs typeface="WPQCJM+FranklinGothic-Book"/>
                   </a:rPr>
-                  <a:t> = 0, 0.35, 0.7 (exchangeable/CS)</a:t>
+                  <a:t> </a:t>
+                </a:r>
+                <a:r>
+                  <a:rPr lang="en-US" sz="2000" dirty="0"/>
+                  <a:t>∈ </a:t>
+                </a:r>
+                <a:r>
+                  <a:rPr lang="en-US" sz="2000" dirty="0">
+                    <a:solidFill>
+                      <a:srgbClr val="181A0D"/>
+                    </a:solidFill>
+                    <a:cs typeface="WPQCJM+FranklinGothic-Book"/>
+                  </a:rPr>
+                  <a:t> {0, 0.35, 0.7} (exchangeable/CS)</a:t>
                 </a:r>
               </a:p>
               <a:p>
@@ -2633,727 +3596,19 @@
                   <a:t>6 data-generating scenarios</a:t>
                 </a:r>
               </a:p>
-            </p:txBody>
-          </p:sp>
-        </mc:Choice>
-        <mc:Fallback>
-          <p:sp>
-            <p:nvSpPr>
-              <p:cNvPr id="4" name="object 4"/>
-              <p:cNvSpPr txBox="1">
-                <a:spLocks noRot="1" noChangeAspect="1" noMove="1" noResize="1" noEditPoints="1" noAdjustHandles="1" noChangeArrowheads="1" noChangeShapeType="1" noTextEdit="1"/>
-              </p:cNvSpPr>
-              <p:nvPr/>
-            </p:nvSpPr>
-            <p:spPr>
-              <a:xfrm>
-                <a:off x="1127448" y="1162497"/>
-                <a:ext cx="9265920" cy="5052665"/>
-              </a:xfrm>
-              <a:prstGeom prst="rect">
-                <a:avLst/>
-              </a:prstGeom>
-              <a:blipFill>
-                <a:blip r:embed="rId4"/>
-                <a:stretch>
-                  <a:fillRect l="-2052" t="-1754" r="-137" b="-2005"/>
-                </a:stretch>
-              </a:blipFill>
-            </p:spPr>
-            <p:txBody>
-              <a:bodyPr/>
-              <a:lstStyle/>
               <a:p>
-                <a:r>
-                  <a:rPr lang="en-US">
-                    <a:noFill/>
-                  </a:rPr>
-                  <a:t> </a:t>
-                </a:r>
-              </a:p>
-            </p:txBody>
-          </p:sp>
-        </mc:Fallback>
-      </mc:AlternateContent>
-    </p:spTree>
-  </p:cSld>
-  <p:clrMapOvr>
-    <a:masterClrMapping/>
-  </p:clrMapOvr>
-</p:sld>
-</file>
-
-<file path=ppt/slides/slide3.xml><?xml version="1.0" encoding="utf-8"?>
-<p:sld xmlns:a="http://schemas.openxmlformats.org/drawingml/2006/main" xmlns:r="http://schemas.openxmlformats.org/officeDocument/2006/relationships" xmlns:p="http://schemas.openxmlformats.org/presentationml/2006/main" showMasterSp="0">
-  <p:cSld>
-    <p:spTree>
-      <p:nvGrpSpPr>
-        <p:cNvPr id="1" name=""/>
-        <p:cNvGrpSpPr/>
-        <p:nvPr/>
-      </p:nvGrpSpPr>
-      <p:grpSpPr>
-        <a:xfrm>
-          <a:off x="0" y="0"/>
-          <a:ext cx="0" cy="0"/>
-          <a:chOff x="0" y="0"/>
-          <a:chExt cx="0" cy="0"/>
-        </a:xfrm>
-      </p:grpSpPr>
-      <p:sp>
-        <p:nvSpPr>
-          <p:cNvPr id="2" name="object 1"/>
-          <p:cNvSpPr/>
-          <p:nvPr/>
-        </p:nvSpPr>
-        <p:spPr>
-          <a:xfrm>
-            <a:off x="0" y="0"/>
-            <a:ext cx="12192000" cy="6858000"/>
-          </a:xfrm>
-          <a:prstGeom prst="rect">
-            <a:avLst/>
-          </a:prstGeom>
-          <a:blipFill>
-            <a:blip r:embed="rId3" cstate="print"/>
-            <a:stretch>
-              <a:fillRect/>
-            </a:stretch>
-          </a:blipFill>
-        </p:spPr>
-        <p:txBody>
-          <a:bodyPr wrap="square" lIns="0" tIns="0" rIns="0" bIns="0" rtlCol="0">
-            <a:spAutoFit/>
-          </a:bodyPr>
-          <a:lstStyle/>
-          <a:p>
-            <a:endParaRPr dirty="0"/>
-          </a:p>
-        </p:txBody>
-      </p:sp>
-      <p:sp>
-        <p:nvSpPr>
-          <p:cNvPr id="3" name="object 3"/>
-          <p:cNvSpPr txBox="1"/>
-          <p:nvPr/>
-        </p:nvSpPr>
-        <p:spPr>
-          <a:xfrm>
-            <a:off x="1055440" y="244403"/>
-            <a:ext cx="7327570" cy="641201"/>
-          </a:xfrm>
-          <a:prstGeom prst="rect">
-            <a:avLst/>
-          </a:prstGeom>
-        </p:spPr>
-        <p:txBody>
-          <a:bodyPr vert="horz" wrap="square" lIns="0" tIns="0" rIns="0" bIns="0" rtlCol="0">
-            <a:spAutoFit/>
-          </a:bodyPr>
-          <a:lstStyle/>
-          <a:p>
-            <a:pPr marL="0" marR="0">
-              <a:lnSpc>
-                <a:spcPts val="4979"/>
-              </a:lnSpc>
-              <a:spcBef>
-                <a:spcPts val="0"/>
-              </a:spcBef>
-              <a:spcAft>
-                <a:spcPts val="0"/>
-              </a:spcAft>
-            </a:pPr>
-            <a:r>
-              <a:rPr lang="en-US" sz="4400" dirty="0">
-                <a:solidFill>
-                  <a:srgbClr val="181A0D"/>
-                </a:solidFill>
-                <a:latin typeface="+mj-lt"/>
-                <a:cs typeface="VTCKGD+FranklinGothic-Book"/>
-              </a:rPr>
-              <a:t>Selection Methods</a:t>
-            </a:r>
-            <a:endParaRPr sz="4400" dirty="0">
-              <a:solidFill>
-                <a:srgbClr val="181A0D"/>
-              </a:solidFill>
-              <a:latin typeface="+mj-lt"/>
-              <a:cs typeface="VTCKGD+FranklinGothic-Book"/>
-            </a:endParaRPr>
-          </a:p>
-        </p:txBody>
-      </p:sp>
-      <mc:AlternateContent xmlns:mc="http://schemas.openxmlformats.org/markup-compatibility/2006">
-        <mc:Choice xmlns:a14="http://schemas.microsoft.com/office/drawing/2010/main" Requires="a14">
-          <p:sp>
-            <p:nvSpPr>
-              <p:cNvPr id="16" name="object 4">
-                <a:extLst>
-                  <a:ext uri="{FF2B5EF4-FFF2-40B4-BE49-F238E27FC236}">
-                    <a16:creationId xmlns:a16="http://schemas.microsoft.com/office/drawing/2014/main" id="{374F020B-F79C-7A71-C268-57FB6096B43E}"/>
-                  </a:ext>
-                </a:extLst>
-              </p:cNvPr>
-              <p:cNvSpPr txBox="1"/>
-              <p:nvPr/>
-            </p:nvSpPr>
-            <p:spPr>
-              <a:xfrm>
-                <a:off x="1127448" y="1162497"/>
-                <a:ext cx="9265920" cy="6194003"/>
-              </a:xfrm>
-              <a:prstGeom prst="rect">
-                <a:avLst/>
-              </a:prstGeom>
-            </p:spPr>
-            <p:txBody>
-              <a:bodyPr vert="horz" wrap="square" lIns="0" tIns="0" rIns="0" bIns="0" rtlCol="0">
-                <a:spAutoFit/>
-              </a:bodyPr>
-              <a:lstStyle/>
-              <a:p>
-                <a:pPr>
-                  <a:lnSpc>
-                    <a:spcPts val="2258"/>
-                  </a:lnSpc>
-                </a:pPr>
-                <a:r>
-                  <a:rPr lang="en-US" sz="2400" b="1" dirty="0">
-                    <a:solidFill>
-                      <a:srgbClr val="181A0D"/>
-                    </a:solidFill>
-                    <a:cs typeface="WPQCJM+FranklinGothic-Book"/>
-                  </a:rPr>
-                  <a:t>Full Model</a:t>
-                </a:r>
-                <a:r>
-                  <a:rPr lang="en-US" sz="2000" b="1" dirty="0">
-                    <a:solidFill>
-                      <a:srgbClr val="181A0D"/>
-                    </a:solidFill>
-                    <a:cs typeface="WPQCJM+FranklinGothic-Book"/>
-                  </a:rPr>
-                  <a:t>:</a:t>
-                </a:r>
-              </a:p>
-              <a:p>
-                <a:pPr marL="800100" lvl="1" indent="-342900">
-                  <a:lnSpc>
-                    <a:spcPts val="2258"/>
-                  </a:lnSpc>
-                  <a:buFont typeface="Wingdings" pitchFamily="2" charset="2"/>
-                  <a:buChar char="Ø"/>
-                </a:pPr>
-                <a:r>
-                  <a:rPr lang="en-US" sz="2000" dirty="0">
-                    <a:solidFill>
-                      <a:srgbClr val="181A0D"/>
-                    </a:solidFill>
-                    <a:cs typeface="WPQCJM+FranklinGothic-Book"/>
-                  </a:rPr>
-                  <a:t>All 20 predictors included</a:t>
-                </a:r>
-              </a:p>
-              <a:p>
-                <a:pPr marL="1257300" lvl="2" indent="-342900">
-                  <a:lnSpc>
-                    <a:spcPts val="2258"/>
-                  </a:lnSpc>
-                  <a:buFont typeface="Wingdings" pitchFamily="2" charset="2"/>
-                  <a:buChar char="§"/>
-                </a:pPr>
-                <a:r>
-                  <a:rPr lang="en-US" sz="2000" dirty="0">
-                    <a:solidFill>
-                      <a:srgbClr val="181A0D"/>
-                    </a:solidFill>
-                    <a:cs typeface="WPQCJM+FranklinGothic-Book"/>
-                  </a:rPr>
-                  <a:t>5 associated with outcome – 15 not</a:t>
-                </a:r>
-              </a:p>
-              <a:p>
-                <a:pPr>
-                  <a:lnSpc>
-                    <a:spcPts val="2258"/>
-                  </a:lnSpc>
-                </a:pPr>
-                <a:endParaRPr lang="en-US" sz="2000" dirty="0">
-                  <a:solidFill>
-                    <a:srgbClr val="181A0D"/>
-                  </a:solidFill>
-                  <a:latin typeface="WPQCJM+FranklinGothic-Book"/>
-                  <a:cs typeface="WPQCJM+FranklinGothic-Book"/>
-                </a:endParaRPr>
-              </a:p>
-              <a:p>
-                <a:pPr marL="285750" indent="-285750">
-                  <a:lnSpc>
-                    <a:spcPts val="2258"/>
-                  </a:lnSpc>
-                  <a:buFont typeface="Wingdings" pitchFamily="2" charset="2"/>
-                  <a:buChar char="q"/>
-                </a:pPr>
-                <a:endParaRPr lang="en-US" sz="2000" dirty="0">
-                  <a:solidFill>
-                    <a:srgbClr val="181A0D"/>
-                  </a:solidFill>
-                  <a:latin typeface="WPQCJM+FranklinGothic-Book"/>
-                  <a:cs typeface="WPQCJM+FranklinGothic-Book"/>
-                </a:endParaRPr>
-              </a:p>
-              <a:p>
-                <a:pPr>
-                  <a:lnSpc>
-                    <a:spcPts val="2258"/>
-                  </a:lnSpc>
-                </a:pPr>
-                <a:r>
-                  <a:rPr lang="en-US" sz="2400" b="1" dirty="0">
-                    <a:solidFill>
-                      <a:srgbClr val="181A0D"/>
-                    </a:solidFill>
-                    <a:cs typeface="WPQCJM+FranklinGothic-Book"/>
-                  </a:rPr>
-                  <a:t>Backward Selection:</a:t>
-                </a:r>
-              </a:p>
-              <a:p>
-                <a:pPr marL="800100" lvl="1" indent="-342900">
-                  <a:lnSpc>
-                    <a:spcPts val="2258"/>
-                  </a:lnSpc>
-                  <a:buFont typeface="Wingdings" pitchFamily="2" charset="2"/>
-                  <a:buChar char="Ø"/>
-                </a:pPr>
-                <a:r>
-                  <a:rPr lang="en-US" sz="2000" dirty="0">
-                    <a:solidFill>
-                      <a:srgbClr val="181A0D"/>
-                    </a:solidFill>
-                    <a:cs typeface="WPQCJM+FranklinGothic-Book"/>
-                  </a:rPr>
-                  <a:t>P-value/F-test (α=0.15)</a:t>
-                </a:r>
-              </a:p>
-              <a:p>
-                <a:pPr marL="800100" lvl="1" indent="-342900">
-                  <a:lnSpc>
-                    <a:spcPts val="2258"/>
-                  </a:lnSpc>
-                  <a:buFont typeface="Wingdings" pitchFamily="2" charset="2"/>
-                  <a:buChar char="Ø"/>
-                </a:pPr>
-                <a:r>
-                  <a:rPr lang="en-US" sz="2000" dirty="0">
-                    <a:solidFill>
-                      <a:srgbClr val="181A0D"/>
-                    </a:solidFill>
-                    <a:cs typeface="WPQCJM+FranklinGothic-Book"/>
-                  </a:rPr>
-                  <a:t>AIC-based selections</a:t>
-                </a:r>
-              </a:p>
-              <a:p>
-                <a:pPr marL="800100" lvl="1" indent="-342900">
-                  <a:lnSpc>
-                    <a:spcPts val="2258"/>
-                  </a:lnSpc>
-                  <a:buFont typeface="Wingdings" pitchFamily="2" charset="2"/>
-                  <a:buChar char="Ø"/>
-                </a:pPr>
-                <a:r>
-                  <a:rPr lang="en-US" sz="2000" dirty="0">
-                    <a:solidFill>
-                      <a:srgbClr val="181A0D"/>
-                    </a:solidFill>
-                    <a:cs typeface="WPQCJM+FranklinGothic-Book"/>
-                  </a:rPr>
-                  <a:t>BIC-based selections</a:t>
-                </a:r>
-              </a:p>
-              <a:p>
-                <a:pPr marL="800100" lvl="1" indent="-342900">
-                  <a:lnSpc>
-                    <a:spcPts val="2258"/>
-                  </a:lnSpc>
-                  <a:buFont typeface="Wingdings" pitchFamily="2" charset="2"/>
-                  <a:buChar char="Ø"/>
-                </a:pPr>
-                <a:endParaRPr lang="en-US" sz="2000" dirty="0">
-                  <a:solidFill>
-                    <a:srgbClr val="181A0D"/>
-                  </a:solidFill>
-                  <a:cs typeface="WPQCJM+FranklinGothic-Book"/>
-                </a:endParaRPr>
-              </a:p>
-              <a:p>
-                <a:pPr lvl="1">
-                  <a:lnSpc>
-                    <a:spcPts val="2258"/>
-                  </a:lnSpc>
-                </a:pPr>
-                <a:endParaRPr lang="en-US" sz="2000" dirty="0">
-                  <a:solidFill>
-                    <a:srgbClr val="181A0D"/>
-                  </a:solidFill>
-                  <a:cs typeface="WPQCJM+FranklinGothic-Book"/>
-                </a:endParaRPr>
-              </a:p>
-              <a:p>
-                <a:pPr>
-                  <a:lnSpc>
-                    <a:spcPts val="2258"/>
-                  </a:lnSpc>
-                </a:pPr>
-                <a:r>
-                  <a:rPr lang="en-US" sz="2400" b="1" dirty="0">
-                    <a:solidFill>
-                      <a:srgbClr val="181A0D"/>
-                    </a:solidFill>
-                    <a:cs typeface="WPQCJM+FranklinGothic-Book"/>
-                  </a:rPr>
-                  <a:t>Penalized Regression:</a:t>
-                </a:r>
-              </a:p>
-              <a:p>
-                <a:pPr marL="800100" lvl="1" indent="-342900">
-                  <a:lnSpc>
-                    <a:spcPts val="2258"/>
-                  </a:lnSpc>
-                  <a:buFont typeface="Wingdings" pitchFamily="2" charset="2"/>
-                  <a:buChar char="Ø"/>
-                </a:pPr>
-                <a:r>
-                  <a:rPr lang="en-US" sz="2000" dirty="0">
-                    <a:solidFill>
-                      <a:srgbClr val="181A0D"/>
-                    </a:solidFill>
-                    <a:cs typeface="WPQCJM+FranklinGothic-Book"/>
-                  </a:rPr>
-                  <a:t>LASSO (</a:t>
-                </a:r>
-                <a14:m>
-                  <m:oMath xmlns:m="http://schemas.openxmlformats.org/officeDocument/2006/math">
-                    <m:sSub>
-                      <m:sSubPr>
-                        <m:ctrlPr>
-                          <a:rPr lang="ar-AE" i="1" smtClean="0">
-                            <a:latin typeface="Cambria Math" panose="02040503050406030204" pitchFamily="18" charset="0"/>
-                          </a:rPr>
-                        </m:ctrlPr>
-                      </m:sSubPr>
-                      <m:e>
-                        <m:r>
-                          <a:rPr lang="ar-AE" i="1">
-                            <a:latin typeface="Cambria Math" panose="02040503050406030204" pitchFamily="18" charset="0"/>
-                          </a:rPr>
-                          <m:t>𝐿</m:t>
-                        </m:r>
-                      </m:e>
-                      <m:sub>
-                        <m:r>
-                          <a:rPr lang="ar-AE" i="1">
-                            <a:latin typeface="Cambria Math" panose="02040503050406030204" pitchFamily="18" charset="0"/>
-                          </a:rPr>
-                          <m:t>1</m:t>
-                        </m:r>
-                      </m:sub>
-                    </m:sSub>
-                    <m:r>
-                      <a:rPr lang="en-US" b="0" i="0" smtClean="0">
-                        <a:latin typeface="Cambria Math" panose="02040503050406030204" pitchFamily="18" charset="0"/>
-                      </a:rPr>
-                      <m:t>)</m:t>
-                    </m:r>
-                  </m:oMath>
-                </a14:m>
-                <a:endParaRPr lang="ar-AE" sz="2000" dirty="0">
-                  <a:solidFill>
-                    <a:srgbClr val="181A0D"/>
-                  </a:solidFill>
-                  <a:cs typeface="WPQCJM+FranklinGothic-Book"/>
-                </a:endParaRPr>
-              </a:p>
-              <a:p>
-                <a:pPr marL="800100" lvl="1" indent="-342900">
-                  <a:lnSpc>
-                    <a:spcPts val="2258"/>
-                  </a:lnSpc>
-                  <a:buFont typeface="Wingdings" pitchFamily="2" charset="2"/>
-                  <a:buChar char="Ø"/>
-                </a:pPr>
-                <a:r>
-                  <a:rPr lang="en-US" sz="2000" dirty="0">
-                    <a:solidFill>
-                      <a:srgbClr val="181A0D"/>
-                    </a:solidFill>
-                    <a:cs typeface="WPQCJM+FranklinGothic-Book"/>
-                  </a:rPr>
-                  <a:t>Elastic Net (</a:t>
-                </a:r>
-                <a14:m>
-                  <m:oMath xmlns:m="http://schemas.openxmlformats.org/officeDocument/2006/math">
-                    <m:sSub>
-                      <m:sSubPr>
-                        <m:ctrlPr>
-                          <a:rPr lang="ar-AE" i="1">
-                            <a:latin typeface="Cambria Math" panose="02040503050406030204" pitchFamily="18" charset="0"/>
-                          </a:rPr>
-                        </m:ctrlPr>
-                      </m:sSubPr>
-                      <m:e>
-                        <m:r>
-                          <a:rPr lang="ar-AE" i="1">
-                            <a:latin typeface="Cambria Math" panose="02040503050406030204" pitchFamily="18" charset="0"/>
-                          </a:rPr>
-                          <m:t>𝐿</m:t>
-                        </m:r>
-                      </m:e>
-                      <m:sub>
-                        <m:r>
-                          <a:rPr lang="ar-AE" i="1">
-                            <a:latin typeface="Cambria Math" panose="02040503050406030204" pitchFamily="18" charset="0"/>
-                          </a:rPr>
-                          <m:t>1</m:t>
-                        </m:r>
-                      </m:sub>
-                    </m:sSub>
-                  </m:oMath>
-                </a14:m>
-                <a:r>
-                  <a:rPr lang="ar-AE" sz="2000" dirty="0"/>
-                  <a:t> + </a:t>
-                </a:r>
-                <a:r>
-                  <a:rPr lang="ar-AE" dirty="0"/>
-                  <a:t> </a:t>
-                </a:r>
-                <a14:m>
-                  <m:oMath xmlns:m="http://schemas.openxmlformats.org/officeDocument/2006/math">
-                    <m:sSub>
-                      <m:sSubPr>
-                        <m:ctrlPr>
-                          <a:rPr lang="ar-AE" i="1">
-                            <a:latin typeface="Cambria Math" panose="02040503050406030204" pitchFamily="18" charset="0"/>
-                          </a:rPr>
-                        </m:ctrlPr>
-                      </m:sSubPr>
-                      <m:e>
-                        <m:r>
-                          <a:rPr lang="ar-AE" i="1">
-                            <a:latin typeface="Cambria Math" panose="02040503050406030204" pitchFamily="18" charset="0"/>
-                          </a:rPr>
-                          <m:t>𝐿</m:t>
-                        </m:r>
-                      </m:e>
-                      <m:sub>
-                        <m:r>
-                          <a:rPr lang="ar-AE" i="1">
-                            <a:latin typeface="Cambria Math" panose="02040503050406030204" pitchFamily="18" charset="0"/>
-                          </a:rPr>
-                          <m:t>2</m:t>
-                        </m:r>
-                      </m:sub>
-                    </m:sSub>
-                  </m:oMath>
-                </a14:m>
-                <a:r>
-                  <a:rPr lang="ar-AE" sz="2000" dirty="0"/>
-                  <a:t> , </a:t>
-                </a:r>
-                <a:r>
-                  <a:rPr lang="el-GR" sz="2000" dirty="0"/>
-                  <a:t>α)</a:t>
-                </a:r>
-              </a:p>
-              <a:p>
-                <a:pPr marL="1257300" lvl="2" indent="-342900">
-                  <a:lnSpc>
-                    <a:spcPts val="2258"/>
-                  </a:lnSpc>
-                  <a:buFont typeface="Wingdings" pitchFamily="2" charset="2"/>
-                  <a:buChar char="§"/>
-                </a:pPr>
-                <a:r>
-                  <a:rPr lang="el-GR" sz="2000" dirty="0">
-                    <a:solidFill>
-                      <a:srgbClr val="181A0D"/>
-                    </a:solidFill>
-                    <a:cs typeface="WPQCJM+FranklinGothic-Book"/>
-                  </a:rPr>
-                  <a:t>α = 0.25, 0.5, 0.75</a:t>
-                </a:r>
-              </a:p>
-              <a:p>
-                <a:pPr marL="800100" lvl="1" indent="-342900">
-                  <a:lnSpc>
-                    <a:spcPts val="2258"/>
-                  </a:lnSpc>
-                  <a:buFont typeface="Wingdings" pitchFamily="2" charset="2"/>
-                  <a:buChar char="Ø"/>
-                </a:pPr>
-                <a:r>
-                  <a:rPr lang="el-GR" sz="2000" dirty="0">
-                    <a:solidFill>
-                      <a:srgbClr val="181A0D"/>
-                    </a:solidFill>
-                    <a:cs typeface="WPQCJM+FranklinGothic-Book"/>
-                  </a:rPr>
-                  <a:t>λ </a:t>
-                </a:r>
-                <a:r>
-                  <a:rPr lang="en-US" sz="2000" dirty="0">
-                    <a:solidFill>
-                      <a:srgbClr val="181A0D"/>
-                    </a:solidFill>
-                    <a:cs typeface="WPQCJM+FranklinGothic-Book"/>
-                  </a:rPr>
-                  <a:t>selected via 10-fold CV</a:t>
-                </a:r>
-              </a:p>
-              <a:p>
-                <a:pPr marL="1257300" lvl="2" indent="-342900">
-                  <a:lnSpc>
-                    <a:spcPts val="2258"/>
-                  </a:lnSpc>
-                  <a:buFont typeface="Wingdings" pitchFamily="2" charset="2"/>
-                  <a:buChar char="§"/>
-                </a:pPr>
-                <a14:m>
-                  <m:oMath xmlns:m="http://schemas.openxmlformats.org/officeDocument/2006/math">
-                    <m:sSub>
-                      <m:sSubPr>
-                        <m:ctrlPr>
-                          <a:rPr lang="ar-AE" i="1">
-                            <a:latin typeface="Cambria Math" panose="02040503050406030204" pitchFamily="18" charset="0"/>
-                          </a:rPr>
-                        </m:ctrlPr>
-                      </m:sSubPr>
-                      <m:e>
-                        <m:r>
-                          <a:rPr lang="ar-AE" b="0" i="1">
-                            <a:latin typeface="Cambria Math" panose="02040503050406030204" pitchFamily="18" charset="0"/>
-                          </a:rPr>
-                          <m:t>𝜆</m:t>
-                        </m:r>
-                      </m:e>
-                      <m:sub>
-                        <m:r>
-                          <a:rPr lang="ar-AE" b="0" i="1">
-                            <a:latin typeface="Cambria Math" panose="02040503050406030204" pitchFamily="18" charset="0"/>
-                          </a:rPr>
-                          <m:t>𝑚𝑖𝑛</m:t>
-                        </m:r>
-                      </m:sub>
-                    </m:sSub>
-                  </m:oMath>
-                </a14:m>
-                <a:r>
-                  <a:rPr lang="ar-AE" sz="2000" dirty="0"/>
-                  <a:t>  </a:t>
-                </a:r>
-                <a:endParaRPr lang="en-US" sz="2000" dirty="0"/>
-              </a:p>
-              <a:p>
-                <a:pPr marL="1257300" lvl="2" indent="-342900">
-                  <a:lnSpc>
-                    <a:spcPts val="2258"/>
-                  </a:lnSpc>
-                  <a:buFont typeface="Wingdings" pitchFamily="2" charset="2"/>
-                  <a:buChar char="§"/>
-                </a:pPr>
-                <a14:m>
-                  <m:oMath xmlns:m="http://schemas.openxmlformats.org/officeDocument/2006/math">
-                    <m:sSub>
-                      <m:sSubPr>
-                        <m:ctrlPr>
-                          <a:rPr lang="ar-AE" i="1">
-                            <a:latin typeface="Cambria Math" panose="02040503050406030204" pitchFamily="18" charset="0"/>
-                          </a:rPr>
-                        </m:ctrlPr>
-                      </m:sSubPr>
-                      <m:e>
-                        <m:r>
-                          <a:rPr lang="ar-AE" i="1">
-                            <a:latin typeface="Cambria Math" panose="02040503050406030204" pitchFamily="18" charset="0"/>
-                          </a:rPr>
-                          <m:t>𝜆</m:t>
-                        </m:r>
-                      </m:e>
-                      <m:sub>
-                        <m:r>
-                          <a:rPr lang="ar-AE" i="1">
-                            <a:latin typeface="Cambria Math" panose="02040503050406030204" pitchFamily="18" charset="0"/>
-                          </a:rPr>
-                          <m:t>1</m:t>
-                        </m:r>
-                        <m:r>
-                          <a:rPr lang="ar-AE" i="1">
-                            <a:latin typeface="Cambria Math" panose="02040503050406030204" pitchFamily="18" charset="0"/>
-                          </a:rPr>
-                          <m:t>𝑠𝑒</m:t>
-                        </m:r>
-                      </m:sub>
-                    </m:sSub>
-                  </m:oMath>
-                </a14:m>
-                <a:endParaRPr lang="ar-AE" sz="2000" dirty="0">
-                  <a:solidFill>
-                    <a:srgbClr val="181A0D"/>
-                  </a:solidFill>
-                  <a:cs typeface="WPQCJM+FranklinGothic-Book"/>
-                </a:endParaRPr>
-              </a:p>
-              <a:p>
-                <a:pPr lvl="1">
-                  <a:lnSpc>
-                    <a:spcPts val="2258"/>
-                  </a:lnSpc>
-                </a:pPr>
-                <a:endParaRPr lang="en-US" sz="2000" dirty="0">
-                  <a:solidFill>
-                    <a:srgbClr val="181A0D"/>
-                  </a:solidFill>
-                  <a:cs typeface="WPQCJM+FranklinGothic-Book"/>
-                </a:endParaRPr>
-              </a:p>
-              <a:p>
-                <a:pPr lvl="1">
-                  <a:lnSpc>
-                    <a:spcPts val="2258"/>
-                  </a:lnSpc>
-                </a:pPr>
-                <a:endParaRPr lang="en-US" sz="2000" dirty="0">
-                  <a:solidFill>
-                    <a:srgbClr val="181A0D"/>
-                  </a:solidFill>
-                  <a:cs typeface="WPQCJM+FranklinGothic-Book"/>
-                </a:endParaRPr>
-              </a:p>
-              <a:p>
-                <a:pPr>
-                  <a:lnSpc>
-                    <a:spcPts val="2258"/>
-                  </a:lnSpc>
-                </a:pPr>
-                <a:endParaRPr lang="en-US" sz="2000" dirty="0">
-                  <a:solidFill>
-                    <a:srgbClr val="181A0D"/>
-                  </a:solidFill>
-                  <a:cs typeface="WPQCJM+FranklinGothic-Book"/>
-                </a:endParaRPr>
+                <a:endParaRPr lang="en-US" dirty="0"/>
               </a:p>
             </p:txBody>
           </p:sp>
         </mc:Choice>
-        <mc:Fallback>
+        <mc:Fallback xmlns="">
           <p:sp>
             <p:nvSpPr>
-              <p:cNvPr id="16" name="object 4">
+              <p:cNvPr id="4" name="TextBox 3">
                 <a:extLst>
                   <a:ext uri="{FF2B5EF4-FFF2-40B4-BE49-F238E27FC236}">
-                    <a16:creationId xmlns:a16="http://schemas.microsoft.com/office/drawing/2014/main" id="{374F020B-F79C-7A71-C268-57FB6096B43E}"/>
+                    <a16:creationId xmlns:a16="http://schemas.microsoft.com/office/drawing/2014/main" id="{617ECB50-2355-E827-B570-C880457499B5}"/>
                   </a:ext>
                 </a:extLst>
               </p:cNvPr>
@@ -3364,16 +3619,16 @@
             </p:nvSpPr>
             <p:spPr>
               <a:xfrm>
-                <a:off x="1127448" y="1162497"/>
-                <a:ext cx="9265920" cy="6194003"/>
+                <a:off x="761425" y="1416279"/>
+                <a:ext cx="6064999" cy="3947234"/>
               </a:xfrm>
               <a:prstGeom prst="rect">
                 <a:avLst/>
               </a:prstGeom>
               <a:blipFill>
-                <a:blip r:embed="rId4"/>
+                <a:blip r:embed="rId5"/>
                 <a:stretch>
-                  <a:fillRect l="-2052" t="-2454"/>
+                  <a:fillRect l="-1674" t="-2885" r="-209"/>
                 </a:stretch>
               </a:blipFill>
             </p:spPr>
@@ -3508,7 +3763,7 @@
         <p:spPr>
           <a:xfrm>
             <a:off x="911424" y="1017600"/>
-            <a:ext cx="9265920" cy="5604098"/>
+            <a:ext cx="9265920" cy="5899051"/>
           </a:xfrm>
           <a:prstGeom prst="rect">
             <a:avLst/>
@@ -3577,7 +3832,7 @@
                 </a:solidFill>
                 <a:cs typeface="WPQCJM+FranklinGothic-Book"/>
               </a:rPr>
-              <a:t>Apply all selection methods</a:t>
+              <a:t>Fit full model w/20 predictors</a:t>
             </a:r>
           </a:p>
           <a:p>
@@ -3595,7 +3850,7 @@
                 </a:solidFill>
                 <a:cs typeface="WPQCJM+FranklinGothic-Book"/>
               </a:rPr>
-              <a:t>Refit final model </a:t>
+              <a:t>Apply all selection methods</a:t>
             </a:r>
           </a:p>
           <a:p>
@@ -3613,7 +3868,25 @@
                 </a:solidFill>
                 <a:cs typeface="WPQCJM+FranklinGothic-Book"/>
               </a:rPr>
-              <a:t>Repeat 1-10k simulations per scenario </a:t>
+              <a:t>Refit final model </a:t>
+            </a:r>
+          </a:p>
+          <a:p>
+            <a:pPr marL="800100" lvl="1" indent="-342900">
+              <a:lnSpc>
+                <a:spcPts val="2258"/>
+              </a:lnSpc>
+              <a:buFont typeface="Wingdings" pitchFamily="2" charset="2"/>
+              <a:buChar char="Ø"/>
+            </a:pPr>
+            <a:r>
+              <a:rPr lang="en-US" sz="2000" dirty="0">
+                <a:solidFill>
+                  <a:srgbClr val="181A0D"/>
+                </a:solidFill>
+                <a:cs typeface="WPQCJM+FranklinGothic-Book"/>
+              </a:rPr>
+              <a:t>Repeat 10k per scenario </a:t>
             </a:r>
           </a:p>
           <a:p>
@@ -3631,7 +3904,7 @@
                 </a:solidFill>
                 <a:cs typeface="WPQCJM+FranklinGothic-Book"/>
               </a:rPr>
-              <a:t>Summarize results as averages</a:t>
+              <a:t>Average across iterations</a:t>
             </a:r>
           </a:p>
           <a:p>

</xml_diff>